<commit_message>
Rozbuduj prezentację: wyjaśnienia wykładowe i źródła akademickie
Więcej slajdów (23), treść z OSTEP, Cambridge, ArchWiki, UEFI i innych
wiarygodnych materiałów; mniejsze oparcie na PDF kompendium.

Co-authored-by: jblaz1 <jblaz1@stu.vistula.edu.pl>
</commit_message>
<xml_diff>
--- a/prezentacja/prezentacja-os.pptx
+++ b/prezentacja/prezentacja-os.pptx
@@ -22,6 +22,12 @@
     <p:sldId id="270" r:id="rId21"/>
     <p:sldId id="271" r:id="rId22"/>
     <p:sldId id="272" r:id="rId23"/>
+    <p:sldId id="273" r:id="rId24"/>
+    <p:sldId id="274" r:id="rId25"/>
+    <p:sldId id="275" r:id="rId26"/>
+    <p:sldId id="276" r:id="rId27"/>
+    <p:sldId id="277" r:id="rId28"/>
+    <p:sldId id="278" r:id="rId29"/>
   </p:sldIdLst>
   <p:sldSz cx="12191695" cy="6858000" type="screen4x3"/>
   <p:notesSz cx="6858000" cy="9144000"/>
@@ -3112,8 +3118,8 @@
         </p:nvSpPr>
         <p:spPr>
           <a:xfrm>
-            <a:off x="731520" y="2011680"/>
-            <a:ext cx="10698480" cy="1828800"/>
+            <a:off x="640080" y="1828800"/>
+            <a:ext cx="10972800" cy="2743200"/>
           </a:xfrm>
           <a:prstGeom prst="rect">
             <a:avLst/>
@@ -3127,7 +3133,7 @@
           <a:lstStyle/>
           <a:p>
             <a:pPr algn="ctr">
-              <a:defRPr sz="4000" b="1">
+              <a:defRPr sz="3600" b="1">
                 <a:solidFill>
                   <a:srgbClr val="1A365D"/>
                 </a:solidFill>
@@ -3144,16 +3150,16 @@
           <a:p>
             <a:pPr algn="ctr">
               <a:spcBef>
-                <a:spcPts val="1800"/>
+                <a:spcPts val="1600"/>
               </a:spcBef>
-              <a:defRPr sz="2200">
-                <a:solidFill>
-                  <a:srgbClr val="444444"/>
-                </a:solidFill>
-              </a:defRPr>
-            </a:pPr>
-            <a:r>
-              <a:t>Systemy operacyjne · ok. 15 min</a:t>
+              <a:defRPr sz="2000">
+                <a:solidFill>
+                  <a:srgbClr val="555555"/>
+                </a:solidFill>
+              </a:defRPr>
+            </a:pPr>
+            <a:r>
+              <a:t>Systemy operacyjne · wykład studencki · ok. 15 min</a:t>
             </a:r>
           </a:p>
         </p:txBody>
@@ -3184,8 +3190,8 @@
         </p:nvSpPr>
         <p:spPr>
           <a:xfrm>
-            <a:off x="548640" y="411480"/>
-            <a:ext cx="11064240" cy="822960"/>
+            <a:off x="502920" y="320040"/>
+            <a:ext cx="11155680" cy="777240"/>
           </a:xfrm>
           <a:prstGeom prst="rect">
             <a:avLst/>
@@ -3199,14 +3205,711 @@
           <a:lstStyle/>
           <a:p>
             <a:pPr>
-              <a:defRPr sz="3000" b="1">
+              <a:defRPr sz="2800" b="1">
                 <a:solidFill>
                   <a:srgbClr val="1A365D"/>
                 </a:solidFill>
               </a:defRPr>
             </a:pPr>
             <a:r>
-              <a:t>Wybrane standardy</a:t>
+              <a:t>Magistrala — definicja i rola</a:t>
+            </a:r>
+          </a:p>
+        </p:txBody>
+      </p:sp>
+      <p:sp>
+        <p:nvSpPr>
+          <p:cNvPr id="3" name="TextBox 2"/>
+          <p:cNvSpPr txBox="1"/>
+          <p:nvPr/>
+        </p:nvSpPr>
+        <p:spPr>
+          <a:xfrm>
+            <a:off x="594360" y="1143000"/>
+            <a:ext cx="10972800" cy="5394960"/>
+          </a:xfrm>
+          <a:prstGeom prst="rect">
+            <a:avLst/>
+          </a:prstGeom>
+          <a:noFill/>
+        </p:spPr>
+        <p:txBody>
+          <a:bodyPr wrap="square">
+            <a:spAutoFit/>
+          </a:bodyPr>
+          <a:lstStyle/>
+          <a:p>
+            <a:pPr>
+              <a:spcAft>
+                <a:spcPts val="800"/>
+              </a:spcAft>
+              <a:defRPr sz="1900">
+                <a:solidFill>
+                  <a:srgbClr val="333333"/>
+                </a:solidFill>
+              </a:defRPr>
+            </a:pPr>
+            <a:r>
+              <a:t>Magistrala to współdzielony (lub logiczny) kanał: przewody, protokół i sygnały, którymi CPU, pamięć i urządzenia wymieniają informacje.</a:t>
+            </a:r>
+          </a:p>
+          <a:p>
+            <a:pPr>
+              <a:spcAft>
+                <a:spcPts val="800"/>
+              </a:spcAft>
+              <a:defRPr sz="1900">
+                <a:solidFill>
+                  <a:srgbClr val="333333"/>
+                </a:solidFill>
+              </a:defRPr>
+            </a:pPr>
+            <a:r>
+              <a:t>W klasycznym modelu magistrala systemowa składa się z trzech funkcji: adres, dane, sterowanie — często mówimy o nich łącznie jako o „system bus”.</a:t>
+            </a:r>
+          </a:p>
+          <a:p>
+            <a:pPr>
+              <a:spcAft>
+                <a:spcPts val="800"/>
+              </a:spcAft>
+              <a:defRPr sz="1900">
+                <a:solidFill>
+                  <a:srgbClr val="333333"/>
+                </a:solidFill>
+              </a:defRPr>
+            </a:pPr>
+            <a:r>
+              <a:t>Szerokość magistrali danych (np. 64 bity) określa, ile bitów przenosi się w jednym cyklu; magistrala adresowa — ile pamięci da się zaadresować (2^n).</a:t>
+            </a:r>
+          </a:p>
+          <a:p>
+            <a:pPr>
+              <a:spcAft>
+                <a:spcPts val="800"/>
+              </a:spcAft>
+              <a:defRPr sz="1900">
+                <a:solidFill>
+                  <a:srgbClr val="333333"/>
+                </a:solidFill>
+              </a:defRPr>
+            </a:pPr>
+            <a:r>
+              <a:t>Magistrale wewnętrzne (CPU–chipset–RAM) vs zewnętrzne / rozszerzeń (PCIe, USB) — różna prędkość i topologia.</a:t>
+            </a:r>
+          </a:p>
+        </p:txBody>
+      </p:sp>
+    </p:spTree>
+  </p:cSld>
+  <p:clrMapOvr>
+    <a:masterClrMapping/>
+  </p:clrMapOvr>
+</p:sld>
+</file>
+
+<file path=ppt/slides/slide11.xml><?xml version="1.0" encoding="utf-8"?>
+<p:sld xmlns:a="http://schemas.openxmlformats.org/drawingml/2006/main" xmlns:p="http://schemas.openxmlformats.org/presentationml/2006/main" xmlns:r="http://schemas.openxmlformats.org/officeDocument/2006/relationships">
+  <p:cSld>
+    <p:spTree>
+      <p:nvGrpSpPr>
+        <p:cNvPr id="1" name=""/>
+        <p:cNvGrpSpPr/>
+        <p:nvPr/>
+      </p:nvGrpSpPr>
+      <p:grpSpPr/>
+      <p:sp>
+        <p:nvSpPr>
+          <p:cNvPr id="2" name="TextBox 1"/>
+          <p:cNvSpPr txBox="1"/>
+          <p:nvPr/>
+        </p:nvSpPr>
+        <p:spPr>
+          <a:xfrm>
+            <a:off x="502920" y="320040"/>
+            <a:ext cx="11155680" cy="777240"/>
+          </a:xfrm>
+          <a:prstGeom prst="rect">
+            <a:avLst/>
+          </a:prstGeom>
+          <a:noFill/>
+        </p:spPr>
+        <p:txBody>
+          <a:bodyPr wrap="none">
+            <a:spAutoFit/>
+          </a:bodyPr>
+          <a:lstStyle/>
+          <a:p>
+            <a:pPr>
+              <a:defRPr sz="2800" b="1">
+                <a:solidFill>
+                  <a:srgbClr val="1A365D"/>
+                </a:solidFill>
+              </a:defRPr>
+            </a:pPr>
+            <a:r>
+              <a:t>Przykład: odczyt z pamięci przez CPU</a:t>
+            </a:r>
+          </a:p>
+        </p:txBody>
+      </p:sp>
+      <p:sp>
+        <p:nvSpPr>
+          <p:cNvPr id="3" name="TextBox 2"/>
+          <p:cNvSpPr txBox="1"/>
+          <p:nvPr/>
+        </p:nvSpPr>
+        <p:spPr>
+          <a:xfrm>
+            <a:off x="594360" y="1143000"/>
+            <a:ext cx="10972800" cy="5394960"/>
+          </a:xfrm>
+          <a:prstGeom prst="rect">
+            <a:avLst/>
+          </a:prstGeom>
+          <a:noFill/>
+        </p:spPr>
+        <p:txBody>
+          <a:bodyPr wrap="square">
+            <a:spAutoFit/>
+          </a:bodyPr>
+          <a:lstStyle/>
+          <a:p>
+            <a:pPr>
+              <a:spcAft>
+                <a:spcPts val="800"/>
+              </a:spcAft>
+              <a:defRPr sz="1900">
+                <a:solidFill>
+                  <a:srgbClr val="333333"/>
+                </a:solidFill>
+              </a:defRPr>
+            </a:pPr>
+            <a:r>
+              <a:t>1. CPU wysyła adres komórki RAM na magistralę adresową.</a:t>
+            </a:r>
+          </a:p>
+          <a:p>
+            <a:pPr>
+              <a:spcAft>
+                <a:spcPts val="800"/>
+              </a:spcAft>
+              <a:defRPr sz="1900">
+                <a:solidFill>
+                  <a:srgbClr val="333333"/>
+                </a:solidFill>
+              </a:defRPr>
+            </a:pPr>
+            <a:r>
+              <a:t>2. Na magistrali sterującej pojawia się sygnał READ (odczyt).</a:t>
+            </a:r>
+          </a:p>
+          <a:p>
+            <a:pPr>
+              <a:spcAft>
+                <a:spcPts val="800"/>
+              </a:spcAft>
+              <a:defRPr sz="1900">
+                <a:solidFill>
+                  <a:srgbClr val="333333"/>
+                </a:solidFill>
+              </a:defRPr>
+            </a:pPr>
+            <a:r>
+              <a:t>3. Układ pamięci umieszcza zawartość komórki na magistrali danych.</a:t>
+            </a:r>
+          </a:p>
+          <a:p>
+            <a:pPr>
+              <a:spcAft>
+                <a:spcPts val="800"/>
+              </a:spcAft>
+              <a:defRPr sz="1900">
+                <a:solidFill>
+                  <a:srgbClr val="333333"/>
+                </a:solidFill>
+              </a:defRPr>
+            </a:pPr>
+            <a:r>
+              <a:t>4. CPU odbiera dane i kontynuuje wykonywanie programu.</a:t>
+            </a:r>
+          </a:p>
+          <a:p>
+            <a:pPr>
+              <a:spcAft>
+                <a:spcPts val="800"/>
+              </a:spcAft>
+              <a:defRPr sz="1900">
+                <a:solidFill>
+                  <a:srgbClr val="333333"/>
+                </a:solidFill>
+              </a:defRPr>
+            </a:pPr>
+            <a:r>
+              <a:t>Ten sam mechanizm (z innymi adresami) służy do memory-mapped I/O — zamiast RAM odpowiada kontroler urządzenia.</a:t>
+            </a:r>
+          </a:p>
+        </p:txBody>
+      </p:sp>
+    </p:spTree>
+  </p:cSld>
+  <p:clrMapOvr>
+    <a:masterClrMapping/>
+  </p:clrMapOvr>
+</p:sld>
+</file>
+
+<file path=ppt/slides/slide12.xml><?xml version="1.0" encoding="utf-8"?>
+<p:sld xmlns:a="http://schemas.openxmlformats.org/drawingml/2006/main" xmlns:p="http://schemas.openxmlformats.org/presentationml/2006/main" xmlns:r="http://schemas.openxmlformats.org/officeDocument/2006/relationships">
+  <p:cSld>
+    <p:spTree>
+      <p:nvGrpSpPr>
+        <p:cNvPr id="1" name=""/>
+        <p:cNvGrpSpPr/>
+        <p:nvPr/>
+      </p:nvGrpSpPr>
+      <p:grpSpPr/>
+      <p:sp>
+        <p:nvSpPr>
+          <p:cNvPr id="2" name="TextBox 1"/>
+          <p:cNvSpPr txBox="1"/>
+          <p:nvPr/>
+        </p:nvSpPr>
+        <p:spPr>
+          <a:xfrm>
+            <a:off x="502920" y="320040"/>
+            <a:ext cx="11155680" cy="777240"/>
+          </a:xfrm>
+          <a:prstGeom prst="rect">
+            <a:avLst/>
+          </a:prstGeom>
+          <a:noFill/>
+        </p:spPr>
+        <p:txBody>
+          <a:bodyPr wrap="none">
+            <a:spAutoFit/>
+          </a:bodyPr>
+          <a:lstStyle/>
+          <a:p>
+            <a:pPr>
+              <a:defRPr sz="2800" b="1">
+                <a:solidFill>
+                  <a:srgbClr val="1A365D"/>
+                </a:solidFill>
+              </a:defRPr>
+            </a:pPr>
+            <a:r>
+              <a:t>Magistrale: adres, danych, sterowania</a:t>
+            </a:r>
+          </a:p>
+        </p:txBody>
+      </p:sp>
+      <p:sp>
+        <p:nvSpPr>
+          <p:cNvPr id="3" name="TextBox 2"/>
+          <p:cNvSpPr txBox="1"/>
+          <p:nvPr/>
+        </p:nvSpPr>
+        <p:spPr>
+          <a:xfrm>
+            <a:off x="502920" y="1051560"/>
+            <a:ext cx="5394960" cy="457200"/>
+          </a:xfrm>
+          <a:prstGeom prst="rect">
+            <a:avLst/>
+          </a:prstGeom>
+          <a:noFill/>
+        </p:spPr>
+        <p:txBody>
+          <a:bodyPr wrap="none">
+            <a:spAutoFit/>
+          </a:bodyPr>
+          <a:lstStyle/>
+          <a:p>
+            <a:pPr>
+              <a:defRPr b="1" sz="2000">
+                <a:solidFill>
+                  <a:srgbClr val="1A365D"/>
+                </a:solidFill>
+              </a:defRPr>
+            </a:pPr>
+            <a:r>
+              <a:t>Magistrala adresowa</a:t>
+            </a:r>
+          </a:p>
+        </p:txBody>
+      </p:sp>
+      <p:sp>
+        <p:nvSpPr>
+          <p:cNvPr id="4" name="TextBox 3"/>
+          <p:cNvSpPr txBox="1"/>
+          <p:nvPr/>
+        </p:nvSpPr>
+        <p:spPr>
+          <a:xfrm>
+            <a:off x="502920" y="1508760"/>
+            <a:ext cx="5394960" cy="4937760"/>
+          </a:xfrm>
+          <a:prstGeom prst="rect">
+            <a:avLst/>
+          </a:prstGeom>
+          <a:noFill/>
+        </p:spPr>
+        <p:txBody>
+          <a:bodyPr wrap="square">
+            <a:spAutoFit/>
+          </a:bodyPr>
+          <a:lstStyle/>
+          <a:p>
+            <a:pPr>
+              <a:spcAft>
+                <a:spcPts val="600"/>
+              </a:spcAft>
+              <a:defRPr sz="1700">
+                <a:solidFill>
+                  <a:srgbClr val="333333"/>
+                </a:solidFill>
+              </a:defRPr>
+            </a:pPr>
+            <a:r>
+              <a:t>Wskazuje lokalizację: RAM lub port I/O.</a:t>
+            </a:r>
+          </a:p>
+          <a:p>
+            <a:pPr>
+              <a:spcAft>
+                <a:spcPts val="600"/>
+              </a:spcAft>
+              <a:defRPr sz="1700">
+                <a:solidFill>
+                  <a:srgbClr val="333333"/>
+                </a:solidFill>
+              </a:defRPr>
+            </a:pPr>
+            <a:r>
+              <a:t>Szerokość → rozmiar adresowanej pamięci.</a:t>
+            </a:r>
+          </a:p>
+          <a:p>
+            <a:pPr>
+              <a:spcAft>
+                <a:spcPts val="600"/>
+              </a:spcAft>
+              <a:defRPr sz="1700">
+                <a:solidFill>
+                  <a:srgbClr val="333333"/>
+                </a:solidFill>
+              </a:defRPr>
+            </a:pPr>
+            <a:r>
+              <a:t>Przykład: 32 linie → do 4 GiB (2^32 bajtów).</a:t>
+            </a:r>
+          </a:p>
+        </p:txBody>
+      </p:sp>
+      <p:sp>
+        <p:nvSpPr>
+          <p:cNvPr id="5" name="TextBox 4"/>
+          <p:cNvSpPr txBox="1"/>
+          <p:nvPr/>
+        </p:nvSpPr>
+        <p:spPr>
+          <a:xfrm>
+            <a:off x="6263640" y="1051560"/>
+            <a:ext cx="5394960" cy="457200"/>
+          </a:xfrm>
+          <a:prstGeom prst="rect">
+            <a:avLst/>
+          </a:prstGeom>
+          <a:noFill/>
+        </p:spPr>
+        <p:txBody>
+          <a:bodyPr wrap="none">
+            <a:spAutoFit/>
+          </a:bodyPr>
+          <a:lstStyle/>
+          <a:p>
+            <a:pPr>
+              <a:defRPr b="1" sz="2000">
+                <a:solidFill>
+                  <a:srgbClr val="1A365D"/>
+                </a:solidFill>
+              </a:defRPr>
+            </a:pPr>
+            <a:r>
+              <a:t>Magistrala danych i sterująca</a:t>
+            </a:r>
+          </a:p>
+        </p:txBody>
+      </p:sp>
+      <p:sp>
+        <p:nvSpPr>
+          <p:cNvPr id="6" name="TextBox 5"/>
+          <p:cNvSpPr txBox="1"/>
+          <p:nvPr/>
+        </p:nvSpPr>
+        <p:spPr>
+          <a:xfrm>
+            <a:off x="6263640" y="1508760"/>
+            <a:ext cx="5394960" cy="4937760"/>
+          </a:xfrm>
+          <a:prstGeom prst="rect">
+            <a:avLst/>
+          </a:prstGeom>
+          <a:noFill/>
+        </p:spPr>
+        <p:txBody>
+          <a:bodyPr wrap="square">
+            <a:spAutoFit/>
+          </a:bodyPr>
+          <a:lstStyle/>
+          <a:p>
+            <a:pPr>
+              <a:spcAft>
+                <a:spcPts val="600"/>
+              </a:spcAft>
+              <a:defRPr sz="1700">
+                <a:solidFill>
+                  <a:srgbClr val="333333"/>
+                </a:solidFill>
+              </a:defRPr>
+            </a:pPr>
+            <a:r>
+              <a:t>Dane: instrukcje i operandy, odpowiedź z pamięci/I/O.</a:t>
+            </a:r>
+          </a:p>
+          <a:p>
+            <a:pPr>
+              <a:spcAft>
+                <a:spcPts val="600"/>
+              </a:spcAft>
+              <a:defRPr sz="1700">
+                <a:solidFill>
+                  <a:srgbClr val="333333"/>
+                </a:solidFill>
+              </a:defRPr>
+            </a:pPr>
+            <a:r>
+              <a:t>Sterowanie: READ/WRITE, zegar, reset, IRQ, arbitraż.</a:t>
+            </a:r>
+          </a:p>
+          <a:p>
+            <a:pPr>
+              <a:spcAft>
+                <a:spcPts val="600"/>
+              </a:spcAft>
+              <a:defRPr sz="1700">
+                <a:solidFill>
+                  <a:srgbClr val="333333"/>
+                </a:solidFill>
+              </a:defRPr>
+            </a:pPr>
+            <a:r>
+              <a:t>Razem tworzą spójny protokół transakcji na szynie.</a:t>
+            </a:r>
+          </a:p>
+        </p:txBody>
+      </p:sp>
+    </p:spTree>
+  </p:cSld>
+  <p:clrMapOvr>
+    <a:masterClrMapping/>
+  </p:clrMapOvr>
+</p:sld>
+</file>
+
+<file path=ppt/slides/slide13.xml><?xml version="1.0" encoding="utf-8"?>
+<p:sld xmlns:a="http://schemas.openxmlformats.org/drawingml/2006/main" xmlns:p="http://schemas.openxmlformats.org/presentationml/2006/main" xmlns:r="http://schemas.openxmlformats.org/officeDocument/2006/relationships">
+  <p:cSld>
+    <p:spTree>
+      <p:nvGrpSpPr>
+        <p:cNvPr id="1" name=""/>
+        <p:cNvGrpSpPr/>
+        <p:nvPr/>
+      </p:nvGrpSpPr>
+      <p:grpSpPr/>
+      <p:sp>
+        <p:nvSpPr>
+          <p:cNvPr id="2" name="TextBox 1"/>
+          <p:cNvSpPr txBox="1"/>
+          <p:nvPr/>
+        </p:nvSpPr>
+        <p:spPr>
+          <a:xfrm>
+            <a:off x="502920" y="320040"/>
+            <a:ext cx="11155680" cy="777240"/>
+          </a:xfrm>
+          <a:prstGeom prst="rect">
+            <a:avLst/>
+          </a:prstGeom>
+          <a:noFill/>
+        </p:spPr>
+        <p:txBody>
+          <a:bodyPr wrap="none">
+            <a:spAutoFit/>
+          </a:bodyPr>
+          <a:lstStyle/>
+          <a:p>
+            <a:pPr>
+              <a:defRPr sz="2800" b="1">
+                <a:solidFill>
+                  <a:srgbClr val="1A365D"/>
+                </a:solidFill>
+              </a:defRPr>
+            </a:pPr>
+            <a:r>
+              <a:t>Od wspólnej szyny równoległej do PCIe</a:t>
+            </a:r>
+          </a:p>
+        </p:txBody>
+      </p:sp>
+      <p:sp>
+        <p:nvSpPr>
+          <p:cNvPr id="3" name="TextBox 2"/>
+          <p:cNvSpPr txBox="1"/>
+          <p:nvPr/>
+        </p:nvSpPr>
+        <p:spPr>
+          <a:xfrm>
+            <a:off x="594360" y="1143000"/>
+            <a:ext cx="10972800" cy="5394960"/>
+          </a:xfrm>
+          <a:prstGeom prst="rect">
+            <a:avLst/>
+          </a:prstGeom>
+          <a:noFill/>
+        </p:spPr>
+        <p:txBody>
+          <a:bodyPr wrap="square">
+            <a:spAutoFit/>
+          </a:bodyPr>
+          <a:lstStyle/>
+          <a:p>
+            <a:pPr>
+              <a:spcAft>
+                <a:spcPts val="800"/>
+              </a:spcAft>
+              <a:defRPr sz="1900">
+                <a:solidFill>
+                  <a:srgbClr val="333333"/>
+                </a:solidFill>
+              </a:defRPr>
+            </a:pPr>
+            <a:r>
+              <a:t>PCI (lat 90.): wspólna magistrala równoległa — urządzenia dzielą linie adresu/danych; arbiter przydziela dostęp.</a:t>
+            </a:r>
+          </a:p>
+          <a:p>
+            <a:pPr>
+              <a:spcAft>
+                <a:spcPts val="800"/>
+              </a:spcAft>
+              <a:defRPr sz="1900">
+                <a:solidFill>
+                  <a:srgbClr val="333333"/>
+                </a:solidFill>
+              </a:defRPr>
+            </a:pPr>
+            <a:r>
+              <a:t>Przy wyższych częstotliwościach: clock skew (bity docierają nierówno) i crosstalk między przewodami — trudno skalować przepustowość.</a:t>
+            </a:r>
+          </a:p>
+          <a:p>
+            <a:pPr>
+              <a:spcAft>
+                <a:spcPts val="800"/>
+              </a:spcAft>
+              <a:defRPr sz="1900">
+                <a:solidFill>
+                  <a:srgbClr val="333333"/>
+                </a:solidFill>
+              </a:defRPr>
+            </a:pPr>
+            <a:r>
+              <a:t>PCI Express: nie wspólna szyna, lecz łącza punkt–punkt (drzewo: root complex → switch → urządzenia).</a:t>
+            </a:r>
+          </a:p>
+          <a:p>
+            <a:pPr>
+              <a:spcAft>
+                <a:spcPts val="800"/>
+              </a:spcAft>
+              <a:defRPr sz="1900">
+                <a:solidFill>
+                  <a:srgbClr val="333333"/>
+                </a:solidFill>
+              </a:defRPr>
+            </a:pPr>
+            <a:r>
+              <a:t>Dane w pakietach po liniach szeregowych (lane); ×4, ×8, ×16 mnoży przepustowość; full-duplex (nadawanie i odbiór równolegle).</a:t>
+            </a:r>
+          </a:p>
+          <a:p>
+            <a:pPr>
+              <a:spcAft>
+                <a:spcPts val="800"/>
+              </a:spcAft>
+              <a:defRPr sz="1900">
+                <a:solidFill>
+                  <a:srgbClr val="333333"/>
+                </a:solidFill>
+              </a:defRPr>
+            </a:pPr>
+            <a:r>
+              <a:t>USB — magistrala szeregowa dla peryferiów (hub, topologia drzewiasta); inna skala niż PCIe, podobna idea warstw protokołu.</a:t>
+            </a:r>
+          </a:p>
+        </p:txBody>
+      </p:sp>
+    </p:spTree>
+  </p:cSld>
+  <p:clrMapOvr>
+    <a:masterClrMapping/>
+  </p:clrMapOvr>
+</p:sld>
+</file>
+
+<file path=ppt/slides/slide14.xml><?xml version="1.0" encoding="utf-8"?>
+<p:sld xmlns:a="http://schemas.openxmlformats.org/drawingml/2006/main" xmlns:p="http://schemas.openxmlformats.org/presentationml/2006/main" xmlns:r="http://schemas.openxmlformats.org/officeDocument/2006/relationships">
+  <p:cSld>
+    <p:spTree>
+      <p:nvGrpSpPr>
+        <p:cNvPr id="1" name=""/>
+        <p:cNvGrpSpPr/>
+        <p:nvPr/>
+      </p:nvGrpSpPr>
+      <p:grpSpPr/>
+      <p:sp>
+        <p:nvSpPr>
+          <p:cNvPr id="2" name="TextBox 1"/>
+          <p:cNvSpPr txBox="1"/>
+          <p:nvPr/>
+        </p:nvSpPr>
+        <p:spPr>
+          <a:xfrm>
+            <a:off x="502920" y="320040"/>
+            <a:ext cx="11155680" cy="777240"/>
+          </a:xfrm>
+          <a:prstGeom prst="rect">
+            <a:avLst/>
+          </a:prstGeom>
+          <a:noFill/>
+        </p:spPr>
+        <p:txBody>
+          <a:bodyPr wrap="none">
+            <a:spAutoFit/>
+          </a:bodyPr>
+          <a:lstStyle/>
+          <a:p>
+            <a:pPr>
+              <a:defRPr sz="2600" b="1">
+                <a:solidFill>
+                  <a:srgbClr val="1A365D"/>
+                </a:solidFill>
+              </a:defRPr>
+            </a:pPr>
+            <a:r>
+              <a:t>PCI a PCI Express (skrót)</a:t>
             </a:r>
           </a:p>
         </p:txBody>
@@ -3220,8 +3923,8 @@
           <p:nvPr/>
         </p:nvGraphicFramePr>
         <p:xfrm>
-          <a:off x="548640" y="1325880"/>
-          <a:ext cx="11064240" cy="1920240"/>
+          <a:off x="502920" y="1097280"/>
+          <a:ext cx="11155680" cy="2377440"/>
         </p:xfrm>
         <a:graphic>
           <a:graphicData uri="http://schemas.openxmlformats.org/drawingml/2006/table">
@@ -3230,25 +3933,25 @@
                 <a:tableStyleId>{5C22544A-7EE6-4342-B048-85BDC9FD1C3A}</a:tableStyleId>
               </a:tblPr>
               <a:tblGrid>
-                <a:gridCol w="3688080"/>
-                <a:gridCol w="3688080"/>
-                <a:gridCol w="3688080"/>
+                <a:gridCol w="2286000"/>
+                <a:gridCol w="4389120"/>
+                <a:gridCol w="4480560"/>
               </a:tblGrid>
-              <a:tr h="480060">
+              <a:tr h="475488">
                 <a:tc>
                   <a:txBody>
                     <a:bodyPr/>
                     <a:lstStyle/>
                     <a:p>
                       <a:pPr>
-                        <a:defRPr b="1" sz="1400">
+                        <a:defRPr b="1" sz="1300">
                           <a:solidFill>
                             <a:srgbClr val="FFFFFF"/>
                           </a:solidFill>
                         </a:defRPr>
                       </a:pPr>
                       <a:r>
-                        <a:t>Standard</a:t>
+                        <a:t>Cecha</a:t>
                       </a:r>
                     </a:p>
                   </a:txBody>
@@ -3264,14 +3967,14 @@
                     <a:lstStyle/>
                     <a:p>
                       <a:pPr>
-                        <a:defRPr b="1" sz="1400">
+                        <a:defRPr b="1" sz="1300">
                           <a:solidFill>
                             <a:srgbClr val="FFFFFF"/>
                           </a:solidFill>
                         </a:defRPr>
                       </a:pPr>
                       <a:r>
-                        <a:t>Typ</a:t>
+                        <a:t>PCI (klasyczny)</a:t>
                       </a:r>
                     </a:p>
                   </a:txBody>
@@ -3287,14 +3990,14 @@
                     <a:lstStyle/>
                     <a:p>
                       <a:pPr>
-                        <a:defRPr b="1" sz="1400">
+                        <a:defRPr b="1" sz="1300">
                           <a:solidFill>
                             <a:srgbClr val="FFFFFF"/>
                           </a:solidFill>
                         </a:defRPr>
                       </a:pPr>
                       <a:r>
-                        <a:t>Zastosowanie</a:t>
+                        <a:t>PCI Express</a:t>
                       </a:r>
                     </a:p>
                   </a:txBody>
@@ -3305,21 +4008,21 @@
                   </a:tcPr>
                 </a:tc>
               </a:tr>
-              <a:tr h="480060">
+              <a:tr h="475488">
                 <a:tc>
                   <a:txBody>
                     <a:bodyPr/>
                     <a:lstStyle/>
                     <a:p>
                       <a:pPr>
-                        <a:defRPr sz="1300">
+                        <a:defRPr sz="1200">
                           <a:solidFill>
-                            <a:srgbClr val="444444"/>
+                            <a:srgbClr val="333333"/>
                           </a:solidFill>
                         </a:defRPr>
                       </a:pPr>
                       <a:r>
-                        <a:t>PCIe</a:t>
+                        <a:t>Topologia</a:t>
                       </a:r>
                     </a:p>
                   </a:txBody>
@@ -3331,14 +4034,14 @@
                     <a:lstStyle/>
                     <a:p>
                       <a:pPr>
-                        <a:defRPr sz="1300">
+                        <a:defRPr sz="1200">
                           <a:solidFill>
-                            <a:srgbClr val="444444"/>
+                            <a:srgbClr val="333333"/>
                           </a:solidFill>
                         </a:defRPr>
                       </a:pPr>
                       <a:r>
-                        <a:t>Szeregowy</a:t>
+                        <a:t>Współdzielona magistrala</a:t>
                       </a:r>
                     </a:p>
                   </a:txBody>
@@ -3350,35 +4053,35 @@
                     <a:lstStyle/>
                     <a:p>
                       <a:pPr>
-                        <a:defRPr sz="1300">
+                        <a:defRPr sz="1200">
                           <a:solidFill>
-                            <a:srgbClr val="444444"/>
+                            <a:srgbClr val="333333"/>
                           </a:solidFill>
                         </a:defRPr>
                       </a:pPr>
                       <a:r>
-                        <a:t>GPU, NVMe</a:t>
+                        <a:t>Punkt–punkt, drzewo</a:t>
                       </a:r>
                     </a:p>
                   </a:txBody>
                   <a:tcPr/>
                 </a:tc>
               </a:tr>
-              <a:tr h="480060">
+              <a:tr h="475488">
                 <a:tc>
                   <a:txBody>
                     <a:bodyPr/>
                     <a:lstStyle/>
                     <a:p>
                       <a:pPr>
-                        <a:defRPr sz="1300">
+                        <a:defRPr sz="1200">
                           <a:solidFill>
-                            <a:srgbClr val="444444"/>
+                            <a:srgbClr val="333333"/>
                           </a:solidFill>
                         </a:defRPr>
                       </a:pPr>
                       <a:r>
-                        <a:t>SATA / M.2</a:t>
+                        <a:t>Transmisja</a:t>
                       </a:r>
                     </a:p>
                   </a:txBody>
@@ -3390,14 +4093,14 @@
                     <a:lstStyle/>
                     <a:p>
                       <a:pPr>
-                        <a:defRPr sz="1300">
+                        <a:defRPr sz="1200">
                           <a:solidFill>
-                            <a:srgbClr val="444444"/>
+                            <a:srgbClr val="333333"/>
                           </a:solidFill>
                         </a:defRPr>
                       </a:pPr>
                       <a:r>
-                        <a:t>Szeregowy</a:t>
+                        <a:t>Równoległa, wspólny zegar</a:t>
                       </a:r>
                     </a:p>
                   </a:txBody>
@@ -3409,35 +4112,35 @@
                     <a:lstStyle/>
                     <a:p>
                       <a:pPr>
-                        <a:defRPr sz="1300">
+                        <a:defRPr sz="1200">
                           <a:solidFill>
-                            <a:srgbClr val="444444"/>
+                            <a:srgbClr val="333333"/>
                           </a:solidFill>
                         </a:defRPr>
                       </a:pPr>
                       <a:r>
-                        <a:t>Dyski</a:t>
+                        <a:t>Szeregowa, pakiety</a:t>
                       </a:r>
                     </a:p>
                   </a:txBody>
                   <a:tcPr/>
                 </a:tc>
               </a:tr>
-              <a:tr h="480060">
+              <a:tr h="475488">
                 <a:tc>
                   <a:txBody>
                     <a:bodyPr/>
                     <a:lstStyle/>
                     <a:p>
                       <a:pPr>
-                        <a:defRPr sz="1300">
+                        <a:defRPr sz="1200">
                           <a:solidFill>
-                            <a:srgbClr val="444444"/>
+                            <a:srgbClr val="333333"/>
                           </a:solidFill>
                         </a:defRPr>
                       </a:pPr>
                       <a:r>
-                        <a:t>USB</a:t>
+                        <a:t>Konflikty</a:t>
                       </a:r>
                     </a:p>
                   </a:txBody>
@@ -3449,14 +4152,14 @@
                     <a:lstStyle/>
                     <a:p>
                       <a:pPr>
-                        <a:defRPr sz="1300">
+                        <a:defRPr sz="1200">
                           <a:solidFill>
-                            <a:srgbClr val="444444"/>
+                            <a:srgbClr val="333333"/>
                           </a:solidFill>
                         </a:defRPr>
                       </a:pPr>
                       <a:r>
-                        <a:t>Szeregowy</a:t>
+                        <a:t>Arbitraż masterów</a:t>
                       </a:r>
                     </a:p>
                   </a:txBody>
@@ -3468,14 +4171,73 @@
                     <a:lstStyle/>
                     <a:p>
                       <a:pPr>
-                        <a:defRPr sz="1300">
+                        <a:defRPr sz="1200">
                           <a:solidFill>
-                            <a:srgbClr val="444444"/>
+                            <a:srgbClr val="333333"/>
                           </a:solidFill>
                         </a:defRPr>
                       </a:pPr>
                       <a:r>
-                        <a:t>Peryferia</a:t>
+                        <a:t>Brak współdzielonej szyny</a:t>
+                      </a:r>
+                    </a:p>
+                  </a:txBody>
+                  <a:tcPr/>
+                </a:tc>
+              </a:tr>
+              <a:tr h="475488">
+                <a:tc>
+                  <a:txBody>
+                    <a:bodyPr/>
+                    <a:lstStyle/>
+                    <a:p>
+                      <a:pPr>
+                        <a:defRPr sz="1200">
+                          <a:solidFill>
+                            <a:srgbClr val="333333"/>
+                          </a:solidFill>
+                        </a:defRPr>
+                      </a:pPr>
+                      <a:r>
+                        <a:t>Typowe użycie</a:t>
+                      </a:r>
+                    </a:p>
+                  </a:txBody>
+                  <a:tcPr/>
+                </a:tc>
+                <a:tc>
+                  <a:txBody>
+                    <a:bodyPr/>
+                    <a:lstStyle/>
+                    <a:p>
+                      <a:pPr>
+                        <a:defRPr sz="1200">
+                          <a:solidFill>
+                            <a:srgbClr val="333333"/>
+                          </a:solidFill>
+                        </a:defRPr>
+                      </a:pPr>
+                      <a:r>
+                        <a:t>Starsze sloty (dziś rzadko)</a:t>
+                      </a:r>
+                    </a:p>
+                  </a:txBody>
+                  <a:tcPr/>
+                </a:tc>
+                <a:tc>
+                  <a:txBody>
+                    <a:bodyPr/>
+                    <a:lstStyle/>
+                    <a:p>
+                      <a:pPr>
+                        <a:defRPr sz="1200">
+                          <a:solidFill>
+                            <a:srgbClr val="333333"/>
+                          </a:solidFill>
+                        </a:defRPr>
+                      </a:pPr>
+                      <a:r>
+                        <a:t>GPU, NVMe, sieć PCIe</a:t>
                       </a:r>
                     </a:p>
                   </a:txBody>
@@ -3494,7 +4256,7 @@
 </p:sld>
 </file>
 
-<file path=ppt/slides/slide11.xml><?xml version="1.0" encoding="utf-8"?>
+<file path=ppt/slides/slide15.xml><?xml version="1.0" encoding="utf-8"?>
 <p:sld xmlns:a="http://schemas.openxmlformats.org/drawingml/2006/main" xmlns:p="http://schemas.openxmlformats.org/presentationml/2006/main" xmlns:r="http://schemas.openxmlformats.org/officeDocument/2006/relationships">
   <p:cSld>
     <p:spTree>
@@ -3512,8 +4274,8 @@
         </p:nvSpPr>
         <p:spPr>
           <a:xfrm>
-            <a:off x="548640" y="411480"/>
-            <a:ext cx="11064240" cy="822960"/>
+            <a:off x="502920" y="320040"/>
+            <a:ext cx="11155680" cy="777240"/>
           </a:xfrm>
           <a:prstGeom prst="rect">
             <a:avLst/>
@@ -3527,14 +4289,14 @@
           <a:lstStyle/>
           <a:p>
             <a:pPr>
-              <a:defRPr sz="3200" b="1">
+              <a:defRPr sz="2800" b="1">
                 <a:solidFill>
                   <a:srgbClr val="1A365D"/>
                 </a:solidFill>
               </a:defRPr>
             </a:pPr>
             <a:r>
-              <a:t>Uruchamianie komputera</a:t>
+              <a:t>Uruchamianie komputera — wprowadzenie</a:t>
             </a:r>
           </a:p>
         </p:txBody>
@@ -3547,8 +4309,8 @@
         </p:nvSpPr>
         <p:spPr>
           <a:xfrm>
-            <a:off x="731520" y="1371600"/>
-            <a:ext cx="10789920" cy="5029200"/>
+            <a:off x="594360" y="1143000"/>
+            <a:ext cx="10972800" cy="5394960"/>
           </a:xfrm>
           <a:prstGeom prst="rect">
             <a:avLst/>
@@ -3563,31 +4325,61 @@
           <a:p>
             <a:pPr>
               <a:spcAft>
-                <a:spcPts val="1000"/>
-              </a:spcAft>
-              <a:defRPr sz="2200">
-                <a:solidFill>
-                  <a:srgbClr val="444444"/>
-                </a:solidFill>
-              </a:defRPr>
-            </a:pPr>
-            <a:r>
-              <a:t>Bootstrapping: od włączenia zasilania do jądra systemu operacyjnego</a:t>
-            </a:r>
-          </a:p>
-          <a:p>
-            <a:pPr>
-              <a:spcAft>
-                <a:spcPts val="1000"/>
-              </a:spcAft>
-              <a:defRPr sz="2200">
-                <a:solidFill>
-                  <a:srgbClr val="444444"/>
-                </a:solidFill>
-              </a:defRPr>
-            </a:pPr>
-            <a:r>
-              <a:t>Firmware na płycie głównej: BIOS (legacy) lub UEFI</a:t>
+                <a:spcPts val="800"/>
+              </a:spcAft>
+              <a:defRPr sz="1900">
+                <a:solidFill>
+                  <a:srgbClr val="333333"/>
+                </a:solidFill>
+              </a:defRPr>
+            </a:pPr>
+            <a:r>
+              <a:t>Bootstrapping: od naciśnięcia przycisku power do momentu, gdy działające jądro SO przejmuje kontrolę nad sprzętem i procesami.</a:t>
+            </a:r>
+          </a:p>
+          <a:p>
+            <a:pPr>
+              <a:spcAft>
+                <a:spcPts val="800"/>
+              </a:spcAft>
+              <a:defRPr sz="1900">
+                <a:solidFill>
+                  <a:srgbClr val="333333"/>
+                </a:solidFill>
+              </a:defRPr>
+            </a:pPr>
+            <a:r>
+              <a:t>Na początku nie ma jeszcze „Windowsa/Linuxa” — tylko firmware w pamięci flash na płycie głównej (BIOS lub UEFI).</a:t>
+            </a:r>
+          </a:p>
+          <a:p>
+            <a:pPr>
+              <a:spcAft>
+                <a:spcPts val="800"/>
+              </a:spcAft>
+              <a:defRPr sz="1900">
+                <a:solidFill>
+                  <a:srgbClr val="333333"/>
+                </a:solidFill>
+              </a:defRPr>
+            </a:pPr>
+            <a:r>
+              <a:t>Firmware musi: przetestować sprzęt, znaleźć nośnik rozruchowy, wczytać bootloader, przekazać mu sterowanie.</a:t>
+            </a:r>
+          </a:p>
+          <a:p>
+            <a:pPr>
+              <a:spcAft>
+                <a:spcPts val="800"/>
+              </a:spcAft>
+              <a:defRPr sz="1900">
+                <a:solidFill>
+                  <a:srgbClr val="333333"/>
+                </a:solidFill>
+              </a:defRPr>
+            </a:pPr>
+            <a:r>
+              <a:t>Bootloader ładuje jądro (+ często initramfs), przekazuje parametry startowe — potem startuje właściwy system operacyjny.</a:t>
             </a:r>
           </a:p>
         </p:txBody>
@@ -3600,7 +4392,7 @@
 </p:sld>
 </file>
 
-<file path=ppt/slides/slide12.xml><?xml version="1.0" encoding="utf-8"?>
+<file path=ppt/slides/slide16.xml><?xml version="1.0" encoding="utf-8"?>
 <p:sld xmlns:a="http://schemas.openxmlformats.org/drawingml/2006/main" xmlns:p="http://schemas.openxmlformats.org/presentationml/2006/main" xmlns:r="http://schemas.openxmlformats.org/officeDocument/2006/relationships">
   <p:cSld>
     <p:spTree>
@@ -3618,8 +4410,8 @@
         </p:nvSpPr>
         <p:spPr>
           <a:xfrm>
-            <a:off x="548640" y="411480"/>
-            <a:ext cx="11064240" cy="822960"/>
+            <a:off x="502920" y="320040"/>
+            <a:ext cx="11155680" cy="777240"/>
           </a:xfrm>
           <a:prstGeom prst="rect">
             <a:avLst/>
@@ -3633,14 +4425,877 @@
           <a:lstStyle/>
           <a:p>
             <a:pPr>
-              <a:defRPr sz="3000" b="1">
+              <a:defRPr sz="2800" b="1">
                 <a:solidFill>
                   <a:srgbClr val="1A365D"/>
                 </a:solidFill>
               </a:defRPr>
             </a:pPr>
             <a:r>
-              <a:t>BIOS a UEFI</a:t>
+              <a:t>POST — Power-On Self-Test</a:t>
+            </a:r>
+          </a:p>
+        </p:txBody>
+      </p:sp>
+      <p:sp>
+        <p:nvSpPr>
+          <p:cNvPr id="3" name="TextBox 2"/>
+          <p:cNvSpPr txBox="1"/>
+          <p:nvPr/>
+        </p:nvSpPr>
+        <p:spPr>
+          <a:xfrm>
+            <a:off x="594360" y="1143000"/>
+            <a:ext cx="10972800" cy="5394960"/>
+          </a:xfrm>
+          <a:prstGeom prst="rect">
+            <a:avLst/>
+          </a:prstGeom>
+          <a:noFill/>
+        </p:spPr>
+        <p:txBody>
+          <a:bodyPr wrap="square">
+            <a:spAutoFit/>
+          </a:bodyPr>
+          <a:lstStyle/>
+          <a:p>
+            <a:pPr>
+              <a:spcAft>
+                <a:spcPts val="800"/>
+              </a:spcAft>
+              <a:defRPr sz="1900">
+                <a:solidFill>
+                  <a:srgbClr val="333333"/>
+                </a:solidFill>
+              </a:defRPr>
+            </a:pPr>
+            <a:r>
+              <a:t>Tuż po zasileniu firmware uruchamia POST: szybka diagnostyka CPU, RAM, podstawowych kontrolerów, czasem GPU.</a:t>
+            </a:r>
+          </a:p>
+          <a:p>
+            <a:pPr>
+              <a:spcAft>
+                <a:spcPts val="800"/>
+              </a:spcAft>
+              <a:defRPr sz="1900">
+                <a:solidFill>
+                  <a:srgbClr val="333333"/>
+                </a:solidFill>
+              </a:defRPr>
+            </a:pPr>
+            <a:r>
+              <a:t>Błędy sygnalizowane kodami dźwiękowymi, komunikatami na ekranie lub kodami POST na płycie.</a:t>
+            </a:r>
+          </a:p>
+          <a:p>
+            <a:pPr>
+              <a:spcAft>
+                <a:spcPts val="800"/>
+              </a:spcAft>
+              <a:defRPr sz="1900">
+                <a:solidFill>
+                  <a:srgbClr val="333333"/>
+                </a:solidFill>
+              </a:defRPr>
+            </a:pPr>
+            <a:r>
+              <a:t>Celem jest upewnienie się, że platforma jest w stanie bezpiecznie wczytać kolejny etap (bootloader).</a:t>
+            </a:r>
+          </a:p>
+          <a:p>
+            <a:pPr>
+              <a:spcAft>
+                <a:spcPts val="800"/>
+              </a:spcAft>
+              <a:defRPr sz="1900">
+                <a:solidFill>
+                  <a:srgbClr val="333333"/>
+                </a:solidFill>
+              </a:defRPr>
+            </a:pPr>
+            <a:r>
+              <a:t>Nowoczesne CPU mają też wcześniejsze etapy inicjalizacji (microcode, trainning pamięci) — POST to warstwa widoczna użytkownikowi.</a:t>
+            </a:r>
+          </a:p>
+        </p:txBody>
+      </p:sp>
+    </p:spTree>
+  </p:cSld>
+  <p:clrMapOvr>
+    <a:masterClrMapping/>
+  </p:clrMapOvr>
+</p:sld>
+</file>
+
+<file path=ppt/slides/slide17.xml><?xml version="1.0" encoding="utf-8"?>
+<p:sld xmlns:a="http://schemas.openxmlformats.org/drawingml/2006/main" xmlns:p="http://schemas.openxmlformats.org/presentationml/2006/main" xmlns:r="http://schemas.openxmlformats.org/officeDocument/2006/relationships">
+  <p:cSld>
+    <p:spTree>
+      <p:nvGrpSpPr>
+        <p:cNvPr id="1" name=""/>
+        <p:cNvGrpSpPr/>
+        <p:nvPr/>
+      </p:nvGrpSpPr>
+      <p:grpSpPr/>
+      <p:sp>
+        <p:nvSpPr>
+          <p:cNvPr id="2" name="TextBox 1"/>
+          <p:cNvSpPr txBox="1"/>
+          <p:nvPr/>
+        </p:nvSpPr>
+        <p:spPr>
+          <a:xfrm>
+            <a:off x="502920" y="320040"/>
+            <a:ext cx="11155680" cy="777240"/>
+          </a:xfrm>
+          <a:prstGeom prst="rect">
+            <a:avLst/>
+          </a:prstGeom>
+          <a:noFill/>
+        </p:spPr>
+        <p:txBody>
+          <a:bodyPr wrap="none">
+            <a:spAutoFit/>
+          </a:bodyPr>
+          <a:lstStyle/>
+          <a:p>
+            <a:pPr>
+              <a:defRPr sz="2800" b="1">
+                <a:solidFill>
+                  <a:srgbClr val="1A365D"/>
+                </a:solidFill>
+              </a:defRPr>
+            </a:pPr>
+            <a:r>
+              <a:t>Ścieżka BIOS (legacy) vs UEFI</a:t>
+            </a:r>
+          </a:p>
+        </p:txBody>
+      </p:sp>
+      <p:sp>
+        <p:nvSpPr>
+          <p:cNvPr id="3" name="TextBox 2"/>
+          <p:cNvSpPr txBox="1"/>
+          <p:nvPr/>
+        </p:nvSpPr>
+        <p:spPr>
+          <a:xfrm>
+            <a:off x="502920" y="1051560"/>
+            <a:ext cx="5394960" cy="457200"/>
+          </a:xfrm>
+          <a:prstGeom prst="rect">
+            <a:avLst/>
+          </a:prstGeom>
+          <a:noFill/>
+        </p:spPr>
+        <p:txBody>
+          <a:bodyPr wrap="none">
+            <a:spAutoFit/>
+          </a:bodyPr>
+          <a:lstStyle/>
+          <a:p>
+            <a:pPr>
+              <a:defRPr b="1" sz="2000">
+                <a:solidFill>
+                  <a:srgbClr val="1A365D"/>
+                </a:solidFill>
+              </a:defRPr>
+            </a:pPr>
+            <a:r>
+              <a:t>BIOS + MBR</a:t>
+            </a:r>
+          </a:p>
+        </p:txBody>
+      </p:sp>
+      <p:sp>
+        <p:nvSpPr>
+          <p:cNvPr id="4" name="TextBox 3"/>
+          <p:cNvSpPr txBox="1"/>
+          <p:nvPr/>
+        </p:nvSpPr>
+        <p:spPr>
+          <a:xfrm>
+            <a:off x="502920" y="1508760"/>
+            <a:ext cx="5394960" cy="4937760"/>
+          </a:xfrm>
+          <a:prstGeom prst="rect">
+            <a:avLst/>
+          </a:prstGeom>
+          <a:noFill/>
+        </p:spPr>
+        <p:txBody>
+          <a:bodyPr wrap="square">
+            <a:spAutoFit/>
+          </a:bodyPr>
+          <a:lstStyle/>
+          <a:p>
+            <a:pPr>
+              <a:spcAft>
+                <a:spcPts val="600"/>
+              </a:spcAft>
+              <a:defRPr sz="1700">
+                <a:solidFill>
+                  <a:srgbClr val="333333"/>
+                </a:solidFill>
+              </a:defRPr>
+            </a:pPr>
+            <a:r>
+              <a:t>Firmware init sprzętu po POST.</a:t>
+            </a:r>
+          </a:p>
+          <a:p>
+            <a:pPr>
+              <a:spcAft>
+                <a:spcPts val="600"/>
+              </a:spcAft>
+              <a:defRPr sz="1700">
+                <a:solidFill>
+                  <a:srgbClr val="333333"/>
+                </a:solidFill>
+              </a:defRPr>
+            </a:pPr>
+            <a:r>
+              <a:t>Kolejność boot z ustawień BIOS.</a:t>
+            </a:r>
+          </a:p>
+          <a:p>
+            <a:pPr>
+              <a:spcAft>
+                <a:spcPts val="600"/>
+              </a:spcAft>
+              <a:defRPr sz="1700">
+                <a:solidFill>
+                  <a:srgbClr val="333333"/>
+                </a:solidFill>
+              </a:defRPr>
+            </a:pPr>
+            <a:r>
+              <a:t>Wczytanie pierwszych 512 B dysku (MBR).</a:t>
+            </a:r>
+          </a:p>
+          <a:p>
+            <a:pPr>
+              <a:spcAft>
+                <a:spcPts val="600"/>
+              </a:spcAft>
+              <a:defRPr sz="1700">
+                <a:solidFill>
+                  <a:srgbClr val="333333"/>
+                </a:solidFill>
+              </a:defRPr>
+            </a:pPr>
+            <a:r>
+              <a:t>Kod MBR → etap 2 bootloadera (np. GRUB).</a:t>
+            </a:r>
+          </a:p>
+          <a:p>
+            <a:pPr>
+              <a:spcAft>
+                <a:spcPts val="600"/>
+              </a:spcAft>
+              <a:defRPr sz="1700">
+                <a:solidFill>
+                  <a:srgbClr val="333333"/>
+                </a:solidFill>
+              </a:defRPr>
+            </a:pPr>
+            <a:r>
+              <a:t>Bootloader ładuje jądro z partycji.</a:t>
+            </a:r>
+          </a:p>
+        </p:txBody>
+      </p:sp>
+      <p:sp>
+        <p:nvSpPr>
+          <p:cNvPr id="5" name="TextBox 4"/>
+          <p:cNvSpPr txBox="1"/>
+          <p:nvPr/>
+        </p:nvSpPr>
+        <p:spPr>
+          <a:xfrm>
+            <a:off x="6263640" y="1051560"/>
+            <a:ext cx="5394960" cy="457200"/>
+          </a:xfrm>
+          <a:prstGeom prst="rect">
+            <a:avLst/>
+          </a:prstGeom>
+          <a:noFill/>
+        </p:spPr>
+        <p:txBody>
+          <a:bodyPr wrap="none">
+            <a:spAutoFit/>
+          </a:bodyPr>
+          <a:lstStyle/>
+          <a:p>
+            <a:pPr>
+              <a:defRPr b="1" sz="2000">
+                <a:solidFill>
+                  <a:srgbClr val="1A365D"/>
+                </a:solidFill>
+              </a:defRPr>
+            </a:pPr>
+            <a:r>
+              <a:t>UEFI</a:t>
+            </a:r>
+          </a:p>
+        </p:txBody>
+      </p:sp>
+      <p:sp>
+        <p:nvSpPr>
+          <p:cNvPr id="6" name="TextBox 5"/>
+          <p:cNvSpPr txBox="1"/>
+          <p:nvPr/>
+        </p:nvSpPr>
+        <p:spPr>
+          <a:xfrm>
+            <a:off x="6263640" y="1508760"/>
+            <a:ext cx="5394960" cy="4937760"/>
+          </a:xfrm>
+          <a:prstGeom prst="rect">
+            <a:avLst/>
+          </a:prstGeom>
+          <a:noFill/>
+        </p:spPr>
+        <p:txBody>
+          <a:bodyPr wrap="square">
+            <a:spAutoFit/>
+          </a:bodyPr>
+          <a:lstStyle/>
+          <a:p>
+            <a:pPr>
+              <a:spcAft>
+                <a:spcPts val="600"/>
+              </a:spcAft>
+              <a:defRPr sz="1700">
+                <a:solidFill>
+                  <a:srgbClr val="333333"/>
+                </a:solidFill>
+              </a:defRPr>
+            </a:pPr>
+            <a:r>
+              <a:t>Init sprzętu; odczyt wpisów boot z NVRAM.</a:t>
+            </a:r>
+          </a:p>
+          <a:p>
+            <a:pPr>
+              <a:spcAft>
+                <a:spcPts val="600"/>
+              </a:spcAft>
+              <a:defRPr sz="1700">
+                <a:solidFill>
+                  <a:srgbClr val="333333"/>
+                </a:solidFill>
+              </a:defRPr>
+            </a:pPr>
+            <a:r>
+              <a:t>Partycja ESP (EFI System Partition).</a:t>
+            </a:r>
+          </a:p>
+          <a:p>
+            <a:pPr>
+              <a:spcAft>
+                <a:spcPts val="600"/>
+              </a:spcAft>
+              <a:defRPr sz="1700">
+                <a:solidFill>
+                  <a:srgbClr val="333333"/>
+                </a:solidFill>
+              </a:defRPr>
+            </a:pPr>
+            <a:r>
+              <a:t>Uruchomienie aplikacji EFI (shim, GRUB, stub jądra).</a:t>
+            </a:r>
+          </a:p>
+          <a:p>
+            <a:pPr>
+              <a:spcAft>
+                <a:spcPts val="600"/>
+              </a:spcAft>
+              <a:defRPr sz="1700">
+                <a:solidFill>
+                  <a:srgbClr val="333333"/>
+                </a:solidFill>
+              </a:defRPr>
+            </a:pPr>
+            <a:r>
+              <a:t>Opcjonalnie Secure Boot — weryfikacja podpisu.</a:t>
+            </a:r>
+          </a:p>
+          <a:p>
+            <a:pPr>
+              <a:spcAft>
+                <a:spcPts val="600"/>
+              </a:spcAft>
+              <a:defRPr sz="1700">
+                <a:solidFill>
+                  <a:srgbClr val="333333"/>
+                </a:solidFill>
+              </a:defRPr>
+            </a:pPr>
+            <a:r>
+              <a:t>Po starcie jądra: ExitBootServices — koniec usług boot firmware.</a:t>
+            </a:r>
+          </a:p>
+        </p:txBody>
+      </p:sp>
+    </p:spTree>
+  </p:cSld>
+  <p:clrMapOvr>
+    <a:masterClrMapping/>
+  </p:clrMapOvr>
+</p:sld>
+</file>
+
+<file path=ppt/slides/slide18.xml><?xml version="1.0" encoding="utf-8"?>
+<p:sld xmlns:a="http://schemas.openxmlformats.org/drawingml/2006/main" xmlns:p="http://schemas.openxmlformats.org/presentationml/2006/main" xmlns:r="http://schemas.openxmlformats.org/officeDocument/2006/relationships">
+  <p:cSld>
+    <p:spTree>
+      <p:nvGrpSpPr>
+        <p:cNvPr id="1" name=""/>
+        <p:cNvGrpSpPr/>
+        <p:nvPr/>
+      </p:nvGrpSpPr>
+      <p:grpSpPr/>
+      <p:sp>
+        <p:nvSpPr>
+          <p:cNvPr id="2" name="TextBox 1"/>
+          <p:cNvSpPr txBox="1"/>
+          <p:nvPr/>
+        </p:nvSpPr>
+        <p:spPr>
+          <a:xfrm>
+            <a:off x="502920" y="320040"/>
+            <a:ext cx="11155680" cy="777240"/>
+          </a:xfrm>
+          <a:prstGeom prst="rect">
+            <a:avLst/>
+          </a:prstGeom>
+          <a:noFill/>
+        </p:spPr>
+        <p:txBody>
+          <a:bodyPr wrap="none">
+            <a:spAutoFit/>
+          </a:bodyPr>
+          <a:lstStyle/>
+          <a:p>
+            <a:pPr>
+              <a:defRPr sz="2800" b="1">
+                <a:solidFill>
+                  <a:srgbClr val="1A365D"/>
+                </a:solidFill>
+              </a:defRPr>
+            </a:pPr>
+            <a:r>
+              <a:t>Bootloader — trzy zadania</a:t>
+            </a:r>
+          </a:p>
+        </p:txBody>
+      </p:sp>
+      <p:sp>
+        <p:nvSpPr>
+          <p:cNvPr id="3" name="TextBox 2"/>
+          <p:cNvSpPr txBox="1"/>
+          <p:nvPr/>
+        </p:nvSpPr>
+        <p:spPr>
+          <a:xfrm>
+            <a:off x="594360" y="1143000"/>
+            <a:ext cx="10972800" cy="5394960"/>
+          </a:xfrm>
+          <a:prstGeom prst="rect">
+            <a:avLst/>
+          </a:prstGeom>
+          <a:noFill/>
+        </p:spPr>
+        <p:txBody>
+          <a:bodyPr wrap="square">
+            <a:spAutoFit/>
+          </a:bodyPr>
+          <a:lstStyle/>
+          <a:p>
+            <a:pPr>
+              <a:spcAft>
+                <a:spcPts val="800"/>
+              </a:spcAft>
+              <a:defRPr sz="1900">
+                <a:solidFill>
+                  <a:srgbClr val="333333"/>
+                </a:solidFill>
+              </a:defRPr>
+            </a:pPr>
+            <a:r>
+              <a:t>Znaleźć jądro na nośniku (plik typu vmlinuz, nt kernel) i wczytać do RAM.</a:t>
+            </a:r>
+          </a:p>
+          <a:p>
+            <a:pPr>
+              <a:spcAft>
+                <a:spcPts val="800"/>
+              </a:spcAft>
+              <a:defRPr sz="1900">
+                <a:solidFill>
+                  <a:srgbClr val="333333"/>
+                </a:solidFill>
+              </a:defRPr>
+            </a:pPr>
+            <a:r>
+              <a:t>Ustawić tryb procesora zgodny z oczekiwaniami jądra (np. long mode x86-64, tabele stronicowania jeśli wymagane).</a:t>
+            </a:r>
+          </a:p>
+          <a:p>
+            <a:pPr>
+              <a:spcAft>
+                <a:spcPts val="800"/>
+              </a:spcAft>
+              <a:defRPr sz="1900">
+                <a:solidFill>
+                  <a:srgbClr val="333333"/>
+                </a:solidFill>
+              </a:defRPr>
+            </a:pPr>
+            <a:r>
+              <a:t>Przekazać informacje, których jądro nie zdobędzie samo: mapa pamięci, wiersz poleceń, initramfs, ramdisk z sterownikami dysku/sieci.</a:t>
+            </a:r>
+          </a:p>
+          <a:p>
+            <a:pPr>
+              <a:spcAft>
+                <a:spcPts val="800"/>
+              </a:spcAft>
+              <a:defRPr sz="1900">
+                <a:solidFill>
+                  <a:srgbClr val="333333"/>
+                </a:solidFill>
+              </a:defRPr>
+            </a:pPr>
+            <a:r>
+              <a:t>Potem skok do punktu wejścia jądra — od tej chwili firmware (prawie) nie steruje maszyną.</a:t>
+            </a:r>
+          </a:p>
+        </p:txBody>
+      </p:sp>
+    </p:spTree>
+  </p:cSld>
+  <p:clrMapOvr>
+    <a:masterClrMapping/>
+  </p:clrMapOvr>
+</p:sld>
+</file>
+
+<file path=ppt/slides/slide19.xml><?xml version="1.0" encoding="utf-8"?>
+<p:sld xmlns:a="http://schemas.openxmlformats.org/drawingml/2006/main" xmlns:p="http://schemas.openxmlformats.org/presentationml/2006/main" xmlns:r="http://schemas.openxmlformats.org/officeDocument/2006/relationships">
+  <p:cSld>
+    <p:spTree>
+      <p:nvGrpSpPr>
+        <p:cNvPr id="1" name=""/>
+        <p:cNvGrpSpPr/>
+        <p:nvPr/>
+      </p:nvGrpSpPr>
+      <p:grpSpPr/>
+      <p:sp>
+        <p:nvSpPr>
+          <p:cNvPr id="2" name="TextBox 1"/>
+          <p:cNvSpPr txBox="1"/>
+          <p:nvPr/>
+        </p:nvSpPr>
+        <p:spPr>
+          <a:xfrm>
+            <a:off x="502920" y="320040"/>
+            <a:ext cx="11155680" cy="777240"/>
+          </a:xfrm>
+          <a:prstGeom prst="rect">
+            <a:avLst/>
+          </a:prstGeom>
+          <a:noFill/>
+        </p:spPr>
+        <p:txBody>
+          <a:bodyPr wrap="none">
+            <a:spAutoFit/>
+          </a:bodyPr>
+          <a:lstStyle/>
+          <a:p>
+            <a:pPr>
+              <a:defRPr sz="2800" b="1">
+                <a:solidFill>
+                  <a:srgbClr val="1A365D"/>
+                </a:solidFill>
+              </a:defRPr>
+            </a:pPr>
+            <a:r>
+              <a:t>Jądro systemu operacyjnego po starcie</a:t>
+            </a:r>
+          </a:p>
+        </p:txBody>
+      </p:sp>
+      <p:sp>
+        <p:nvSpPr>
+          <p:cNvPr id="3" name="TextBox 2"/>
+          <p:cNvSpPr txBox="1"/>
+          <p:nvPr/>
+        </p:nvSpPr>
+        <p:spPr>
+          <a:xfrm>
+            <a:off x="594360" y="1143000"/>
+            <a:ext cx="10972800" cy="5394960"/>
+          </a:xfrm>
+          <a:prstGeom prst="rect">
+            <a:avLst/>
+          </a:prstGeom>
+          <a:noFill/>
+        </p:spPr>
+        <p:txBody>
+          <a:bodyPr wrap="square">
+            <a:spAutoFit/>
+          </a:bodyPr>
+          <a:lstStyle/>
+          <a:p>
+            <a:pPr>
+              <a:spcAft>
+                <a:spcPts val="800"/>
+              </a:spcAft>
+              <a:defRPr sz="1900">
+                <a:solidFill>
+                  <a:srgbClr val="333333"/>
+                </a:solidFill>
+              </a:defRPr>
+            </a:pPr>
+            <a:r>
+              <a:t>Jądro ponownie wykrywa sprzęt, ładuje sterowniki (dysk, klawiatura, sieć…).</a:t>
+            </a:r>
+          </a:p>
+          <a:p>
+            <a:pPr>
+              <a:spcAft>
+                <a:spcPts val="800"/>
+              </a:spcAft>
+              <a:defRPr sz="1900">
+                <a:solidFill>
+                  <a:srgbClr val="333333"/>
+                </a:solidFill>
+              </a:defRPr>
+            </a:pPr>
+            <a:r>
+              <a:t>Montuje system plików root, uruchamia proces init (systemd itd.) — usługi, logowanie, pulpit.</a:t>
+            </a:r>
+          </a:p>
+          <a:p>
+            <a:pPr>
+              <a:spcAft>
+                <a:spcPts val="800"/>
+              </a:spcAft>
+              <a:defRPr sz="1900">
+                <a:solidFill>
+                  <a:srgbClr val="333333"/>
+                </a:solidFill>
+              </a:defRPr>
+            </a:pPr>
+            <a:r>
+              <a:t>Dopiero teraz w pełni działają abstrakcje SO omawiane przy I/O: pliki, procesy, scheduler, pamięć wirtualna.</a:t>
+            </a:r>
+          </a:p>
+          <a:p>
+            <a:pPr>
+              <a:spcAft>
+                <a:spcPts val="800"/>
+              </a:spcAft>
+              <a:defRPr sz="1900">
+                <a:solidFill>
+                  <a:srgbClr val="333333"/>
+                </a:solidFill>
+              </a:defRPr>
+            </a:pPr>
+            <a:r>
+              <a:t>Cały łańcuch POST → firmware → bootloader → kernel wyjaśnia, dlaczego błąd dysku rozruchowego zatrzymuje boot zanim wystartuje OS.</a:t>
+            </a:r>
+          </a:p>
+        </p:txBody>
+      </p:sp>
+    </p:spTree>
+  </p:cSld>
+  <p:clrMapOvr>
+    <a:masterClrMapping/>
+  </p:clrMapOvr>
+</p:sld>
+</file>
+
+<file path=ppt/slides/slide2.xml><?xml version="1.0" encoding="utf-8"?>
+<p:sld xmlns:a="http://schemas.openxmlformats.org/drawingml/2006/main" xmlns:p="http://schemas.openxmlformats.org/presentationml/2006/main" xmlns:r="http://schemas.openxmlformats.org/officeDocument/2006/relationships">
+  <p:cSld>
+    <p:spTree>
+      <p:nvGrpSpPr>
+        <p:cNvPr id="1" name=""/>
+        <p:cNvGrpSpPr/>
+        <p:nvPr/>
+      </p:nvGrpSpPr>
+      <p:grpSpPr/>
+      <p:sp>
+        <p:nvSpPr>
+          <p:cNvPr id="2" name="TextBox 1"/>
+          <p:cNvSpPr txBox="1"/>
+          <p:nvPr/>
+        </p:nvSpPr>
+        <p:spPr>
+          <a:xfrm>
+            <a:off x="502920" y="320040"/>
+            <a:ext cx="11155680" cy="777240"/>
+          </a:xfrm>
+          <a:prstGeom prst="rect">
+            <a:avLst/>
+          </a:prstGeom>
+          <a:noFill/>
+        </p:spPr>
+        <p:txBody>
+          <a:bodyPr wrap="none">
+            <a:spAutoFit/>
+          </a:bodyPr>
+          <a:lstStyle/>
+          <a:p>
+            <a:pPr>
+              <a:defRPr sz="2800" b="1">
+                <a:solidFill>
+                  <a:srgbClr val="1A365D"/>
+                </a:solidFill>
+              </a:defRPr>
+            </a:pPr>
+            <a:r>
+              <a:t>Po tej prezentacji powinieneś umieć</a:t>
+            </a:r>
+          </a:p>
+        </p:txBody>
+      </p:sp>
+      <p:sp>
+        <p:nvSpPr>
+          <p:cNvPr id="3" name="TextBox 2"/>
+          <p:cNvSpPr txBox="1"/>
+          <p:nvPr/>
+        </p:nvSpPr>
+        <p:spPr>
+          <a:xfrm>
+            <a:off x="594360" y="1143000"/>
+            <a:ext cx="10972800" cy="5394960"/>
+          </a:xfrm>
+          <a:prstGeom prst="rect">
+            <a:avLst/>
+          </a:prstGeom>
+          <a:noFill/>
+        </p:spPr>
+        <p:txBody>
+          <a:bodyPr wrap="square">
+            <a:spAutoFit/>
+          </a:bodyPr>
+          <a:lstStyle/>
+          <a:p>
+            <a:pPr>
+              <a:spcAft>
+                <a:spcPts val="800"/>
+              </a:spcAft>
+              <a:defRPr sz="2000">
+                <a:solidFill>
+                  <a:srgbClr val="333333"/>
+                </a:solidFill>
+              </a:defRPr>
+            </a:pPr>
+            <a:r>
+              <a:t>Wyjaśnić, jak procesor współpracuje z urządzeniami zewnętrznymi i po co jest warstwa OS.</a:t>
+            </a:r>
+          </a:p>
+          <a:p>
+            <a:pPr>
+              <a:spcAft>
+                <a:spcPts val="800"/>
+              </a:spcAft>
+              <a:defRPr sz="2000">
+                <a:solidFill>
+                  <a:srgbClr val="333333"/>
+                </a:solidFill>
+              </a:defRPr>
+            </a:pPr>
+            <a:r>
+              <a:t>Porównać odpytywanie, I/O sterowane przerwaniami oraz DMA — z przykładami zastosowań.</a:t>
+            </a:r>
+          </a:p>
+          <a:p>
+            <a:pPr>
+              <a:spcAft>
+                <a:spcPts val="800"/>
+              </a:spcAft>
+              <a:defRPr sz="2000">
+                <a:solidFill>
+                  <a:srgbClr val="333333"/>
+                </a:solidFill>
+              </a:defRPr>
+            </a:pPr>
+            <a:r>
+              <a:t>Opisać rolę magistral (adres, danych, sterowania) oraz różnicę PCI vs PCIe.</a:t>
+            </a:r>
+          </a:p>
+          <a:p>
+            <a:pPr>
+              <a:spcAft>
+                <a:spcPts val="800"/>
+              </a:spcAft>
+              <a:defRPr sz="2000">
+                <a:solidFill>
+                  <a:srgbClr val="333333"/>
+                </a:solidFill>
+              </a:defRPr>
+            </a:pPr>
+            <a:r>
+              <a:t>Prześledzić rozruch PC: POST → firmware → bootloader → jądro systemu operacyjnego.</a:t>
+            </a:r>
+          </a:p>
+        </p:txBody>
+      </p:sp>
+    </p:spTree>
+  </p:cSld>
+  <p:clrMapOvr>
+    <a:masterClrMapping/>
+  </p:clrMapOvr>
+</p:sld>
+</file>
+
+<file path=ppt/slides/slide20.xml><?xml version="1.0" encoding="utf-8"?>
+<p:sld xmlns:a="http://schemas.openxmlformats.org/drawingml/2006/main" xmlns:p="http://schemas.openxmlformats.org/presentationml/2006/main" xmlns:r="http://schemas.openxmlformats.org/officeDocument/2006/relationships">
+  <p:cSld>
+    <p:spTree>
+      <p:nvGrpSpPr>
+        <p:cNvPr id="1" name=""/>
+        <p:cNvGrpSpPr/>
+        <p:nvPr/>
+      </p:nvGrpSpPr>
+      <p:grpSpPr/>
+      <p:sp>
+        <p:nvSpPr>
+          <p:cNvPr id="2" name="TextBox 1"/>
+          <p:cNvSpPr txBox="1"/>
+          <p:nvPr/>
+        </p:nvSpPr>
+        <p:spPr>
+          <a:xfrm>
+            <a:off x="502920" y="320040"/>
+            <a:ext cx="11155680" cy="777240"/>
+          </a:xfrm>
+          <a:prstGeom prst="rect">
+            <a:avLst/>
+          </a:prstGeom>
+          <a:noFill/>
+        </p:spPr>
+        <p:txBody>
+          <a:bodyPr wrap="none">
+            <a:spAutoFit/>
+          </a:bodyPr>
+          <a:lstStyle/>
+          <a:p>
+            <a:pPr>
+              <a:defRPr sz="2600" b="1">
+                <a:solidFill>
+                  <a:srgbClr val="1A365D"/>
+                </a:solidFill>
+              </a:defRPr>
+            </a:pPr>
+            <a:r>
+              <a:t>MBR a GPT — praktyczne różnice</a:t>
             </a:r>
           </a:p>
         </p:txBody>
@@ -3654,8 +5309,8 @@
           <p:nvPr/>
         </p:nvGraphicFramePr>
         <p:xfrm>
-          <a:off x="548640" y="1325880"/>
-          <a:ext cx="11064240" cy="1920240"/>
+          <a:off x="502920" y="1097280"/>
+          <a:ext cx="11155680" cy="2377440"/>
         </p:xfrm>
         <a:graphic>
           <a:graphicData uri="http://schemas.openxmlformats.org/drawingml/2006/table">
@@ -3664,18 +5319,18 @@
                 <a:tableStyleId>{5C22544A-7EE6-4342-B048-85BDC9FD1C3A}</a:tableStyleId>
               </a:tblPr>
               <a:tblGrid>
-                <a:gridCol w="3688080"/>
-                <a:gridCol w="3688080"/>
-                <a:gridCol w="3688080"/>
+                <a:gridCol w="2011680"/>
+                <a:gridCol w="4572000"/>
+                <a:gridCol w="4572000"/>
               </a:tblGrid>
-              <a:tr h="480060">
+              <a:tr h="475488">
                 <a:tc>
                   <a:txBody>
                     <a:bodyPr/>
                     <a:lstStyle/>
                     <a:p>
                       <a:pPr>
-                        <a:defRPr b="1" sz="1400">
+                        <a:defRPr b="1" sz="1300">
                           <a:solidFill>
                             <a:srgbClr val="FFFFFF"/>
                           </a:solidFill>
@@ -3695,14 +5350,14 @@
                     <a:lstStyle/>
                     <a:p>
                       <a:pPr>
-                        <a:defRPr b="1" sz="1400">
+                        <a:defRPr b="1" sz="1300">
                           <a:solidFill>
                             <a:srgbClr val="FFFFFF"/>
                           </a:solidFill>
                         </a:defRPr>
                       </a:pPr>
                       <a:r>
-                        <a:t>BIOS</a:t>
+                        <a:t>MBR</a:t>
                       </a:r>
                     </a:p>
                   </a:txBody>
@@ -3718,14 +5373,14 @@
                     <a:lstStyle/>
                     <a:p>
                       <a:pPr>
-                        <a:defRPr b="1" sz="1400">
+                        <a:defRPr b="1" sz="1300">
                           <a:solidFill>
                             <a:srgbClr val="FFFFFF"/>
                           </a:solidFill>
                         </a:defRPr>
                       </a:pPr>
                       <a:r>
-                        <a:t>UEFI</a:t>
+                        <a:t>GPT</a:t>
                       </a:r>
                     </a:p>
                   </a:txBody>
@@ -3736,16 +5391,75 @@
                   </a:tcPr>
                 </a:tc>
               </a:tr>
-              <a:tr h="480060">
+              <a:tr h="475488">
                 <a:tc>
                   <a:txBody>
                     <a:bodyPr/>
                     <a:lstStyle/>
                     <a:p>
                       <a:pPr>
-                        <a:defRPr sz="1300">
+                        <a:defRPr sz="1200">
                           <a:solidFill>
-                            <a:srgbClr val="444444"/>
+                            <a:srgbClr val="333333"/>
+                          </a:solidFill>
+                        </a:defRPr>
+                      </a:pPr>
+                      <a:r>
+                        <a:t>Rozmiar dysku</a:t>
+                      </a:r>
+                    </a:p>
+                  </a:txBody>
+                  <a:tcPr/>
+                </a:tc>
+                <a:tc>
+                  <a:txBody>
+                    <a:bodyPr/>
+                    <a:lstStyle/>
+                    <a:p>
+                      <a:pPr>
+                        <a:defRPr sz="1200">
+                          <a:solidFill>
+                            <a:srgbClr val="333333"/>
+                          </a:solidFill>
+                        </a:defRPr>
+                      </a:pPr>
+                      <a:r>
+                        <a:t>Praktyczny limit ~2 TB</a:t>
+                      </a:r>
+                    </a:p>
+                  </a:txBody>
+                  <a:tcPr/>
+                </a:tc>
+                <a:tc>
+                  <a:txBody>
+                    <a:bodyPr/>
+                    <a:lstStyle/>
+                    <a:p>
+                      <a:pPr>
+                        <a:defRPr sz="1200">
+                          <a:solidFill>
+                            <a:srgbClr val="333333"/>
+                          </a:solidFill>
+                        </a:defRPr>
+                      </a:pPr>
+                      <a:r>
+                        <a:t>Dużo większe wolumeny</a:t>
+                      </a:r>
+                    </a:p>
+                  </a:txBody>
+                  <a:tcPr/>
+                </a:tc>
+              </a:tr>
+              <a:tr h="475488">
+                <a:tc>
+                  <a:txBody>
+                    <a:bodyPr/>
+                    <a:lstStyle/>
+                    <a:p>
+                      <a:pPr>
+                        <a:defRPr sz="1200">
+                          <a:solidFill>
+                            <a:srgbClr val="333333"/>
                           </a:solidFill>
                         </a:defRPr>
                       </a:pPr>
@@ -3762,14 +5476,14 @@
                     <a:lstStyle/>
                     <a:p>
                       <a:pPr>
-                        <a:defRPr sz="1300">
+                        <a:defRPr sz="1200">
                           <a:solidFill>
-                            <a:srgbClr val="444444"/>
+                            <a:srgbClr val="333333"/>
                           </a:solidFill>
                         </a:defRPr>
                       </a:pPr>
                       <a:r>
-                        <a:t>MBR (~2 TB, 4 podst.)</a:t>
+                        <a:t>4 podstawowe (+ rozszerzona)</a:t>
                       </a:r>
                     </a:p>
                   </a:txBody>
@@ -3781,35 +5495,35 @@
                     <a:lstStyle/>
                     <a:p>
                       <a:pPr>
-                        <a:defRPr sz="1300">
+                        <a:defRPr sz="1200">
                           <a:solidFill>
-                            <a:srgbClr val="444444"/>
+                            <a:srgbClr val="333333"/>
                           </a:solidFill>
                         </a:defRPr>
                       </a:pPr>
                       <a:r>
-                        <a:t>GPT (&gt;2 TB)</a:t>
+                        <a:t>Wiele partycji (standard UEFI)</a:t>
                       </a:r>
                     </a:p>
                   </a:txBody>
                   <a:tcPr/>
                 </a:tc>
               </a:tr>
-              <a:tr h="480060">
+              <a:tr h="475488">
                 <a:tc>
                   <a:txBody>
                     <a:bodyPr/>
                     <a:lstStyle/>
                     <a:p>
                       <a:pPr>
-                        <a:defRPr sz="1300">
+                        <a:defRPr sz="1200">
                           <a:solidFill>
-                            <a:srgbClr val="444444"/>
+                            <a:srgbClr val="333333"/>
                           </a:solidFill>
                         </a:defRPr>
                       </a:pPr>
                       <a:r>
-                        <a:t>Interfejs</a:t>
+                        <a:t>Typowy firmware</a:t>
                       </a:r>
                     </a:p>
                   </a:txBody>
@@ -3821,14 +5535,14 @@
                     <a:lstStyle/>
                     <a:p>
                       <a:pPr>
-                        <a:defRPr sz="1300">
+                        <a:defRPr sz="1200">
                           <a:solidFill>
-                            <a:srgbClr val="444444"/>
+                            <a:srgbClr val="333333"/>
                           </a:solidFill>
                         </a:defRPr>
                       </a:pPr>
                       <a:r>
-                        <a:t>Tekstowy</a:t>
+                        <a:t>BIOS</a:t>
                       </a:r>
                     </a:p>
                   </a:txBody>
@@ -3840,35 +5554,35 @@
                     <a:lstStyle/>
                     <a:p>
                       <a:pPr>
-                        <a:defRPr sz="1300">
+                        <a:defRPr sz="1200">
                           <a:solidFill>
-                            <a:srgbClr val="444444"/>
+                            <a:srgbClr val="333333"/>
                           </a:solidFill>
                         </a:defRPr>
                       </a:pPr>
                       <a:r>
-                        <a:t>Graficzny</a:t>
+                        <a:t>UEFI (+ często Secure Boot)</a:t>
                       </a:r>
                     </a:p>
                   </a:txBody>
                   <a:tcPr/>
                 </a:tc>
               </a:tr>
-              <a:tr h="480060">
+              <a:tr h="475488">
                 <a:tc>
                   <a:txBody>
                     <a:bodyPr/>
                     <a:lstStyle/>
                     <a:p>
                       <a:pPr>
-                        <a:defRPr sz="1300">
+                        <a:defRPr sz="1200">
                           <a:solidFill>
-                            <a:srgbClr val="444444"/>
+                            <a:srgbClr val="333333"/>
                           </a:solidFill>
                         </a:defRPr>
                       </a:pPr>
                       <a:r>
-                        <a:t>Bezpieczeństwo</a:t>
+                        <a:t>Rozruch</a:t>
                       </a:r>
                     </a:p>
                   </a:txBody>
@@ -3880,14 +5594,14 @@
                     <a:lstStyle/>
                     <a:p>
                       <a:pPr>
-                        <a:defRPr sz="1300">
+                        <a:defRPr sz="1200">
                           <a:solidFill>
-                            <a:srgbClr val="444444"/>
+                            <a:srgbClr val="333333"/>
                           </a:solidFill>
                         </a:defRPr>
                       </a:pPr>
                       <a:r>
-                        <a:t>Ograniczone</a:t>
+                        <a:t>Sektor 512 B + kod bootloadera</a:t>
                       </a:r>
                     </a:p>
                   </a:txBody>
@@ -3899,14 +5613,14 @@
                     <a:lstStyle/>
                     <a:p>
                       <a:pPr>
-                        <a:defRPr sz="1300">
+                        <a:defRPr sz="1200">
                           <a:solidFill>
-                            <a:srgbClr val="444444"/>
+                            <a:srgbClr val="333333"/>
                           </a:solidFill>
                         </a:defRPr>
                       </a:pPr>
                       <a:r>
-                        <a:t>Secure Boot</a:t>
+                        <a:t>Partycja ESP + aplikacje .efi</a:t>
                       </a:r>
                     </a:p>
                   </a:txBody>
@@ -3925,7 +5639,7 @@
 </p:sld>
 </file>
 
-<file path=ppt/slides/slide13.xml><?xml version="1.0" encoding="utf-8"?>
+<file path=ppt/slides/slide21.xml><?xml version="1.0" encoding="utf-8"?>
 <p:sld xmlns:a="http://schemas.openxmlformats.org/drawingml/2006/main" xmlns:p="http://schemas.openxmlformats.org/presentationml/2006/main" xmlns:r="http://schemas.openxmlformats.org/officeDocument/2006/relationships">
   <p:cSld>
     <p:spTree>
@@ -3943,8 +5657,8 @@
         </p:nvSpPr>
         <p:spPr>
           <a:xfrm>
-            <a:off x="548640" y="411480"/>
-            <a:ext cx="11064240" cy="822960"/>
+            <a:off x="502920" y="320040"/>
+            <a:ext cx="11155680" cy="777240"/>
           </a:xfrm>
           <a:prstGeom prst="rect">
             <a:avLst/>
@@ -3958,14 +5672,14 @@
           <a:lstStyle/>
           <a:p>
             <a:pPr>
-              <a:defRPr sz="3200" b="1">
+              <a:defRPr sz="2800" b="1">
                 <a:solidFill>
                   <a:srgbClr val="1A365D"/>
                 </a:solidFill>
               </a:defRPr>
             </a:pPr>
             <a:r>
-              <a:t>Etapy rozruchu</a:t>
+              <a:t>Podsumowanie</a:t>
             </a:r>
           </a:p>
         </p:txBody>
@@ -3978,8 +5692,8 @@
         </p:nvSpPr>
         <p:spPr>
           <a:xfrm>
-            <a:off x="731520" y="1371600"/>
-            <a:ext cx="10789920" cy="5029200"/>
+            <a:off x="594360" y="1143000"/>
+            <a:ext cx="10972800" cy="5394960"/>
           </a:xfrm>
           <a:prstGeom prst="rect">
             <a:avLst/>
@@ -3994,76 +5708,61 @@
           <a:p>
             <a:pPr>
               <a:spcAft>
-                <a:spcPts val="1000"/>
-              </a:spcAft>
-              <a:defRPr sz="2200">
-                <a:solidFill>
-                  <a:srgbClr val="444444"/>
-                </a:solidFill>
-              </a:defRPr>
-            </a:pPr>
-            <a:r>
-              <a:t>1. POST — test sprzętu (CPU, RAM, GPU…)</a:t>
-            </a:r>
-          </a:p>
-          <a:p>
-            <a:pPr>
-              <a:spcAft>
-                <a:spcPts val="1000"/>
-              </a:spcAft>
-              <a:defRPr sz="2200">
-                <a:solidFill>
-                  <a:srgbClr val="444444"/>
-                </a:solidFill>
-              </a:defRPr>
-            </a:pPr>
-            <a:r>
-              <a:t>2. Wybór nośnika rozruchowego (MBR / EFI System)</a:t>
-            </a:r>
-          </a:p>
-          <a:p>
-            <a:pPr>
-              <a:spcAft>
-                <a:spcPts val="1000"/>
-              </a:spcAft>
-              <a:defRPr sz="2200">
-                <a:solidFill>
-                  <a:srgbClr val="444444"/>
-                </a:solidFill>
-              </a:defRPr>
-            </a:pPr>
-            <a:r>
-              <a:t>3. Bootloader (GRUB, Windows Boot Manager)</a:t>
-            </a:r>
-          </a:p>
-          <a:p>
-            <a:pPr>
-              <a:spcAft>
-                <a:spcPts val="1000"/>
-              </a:spcAft>
-              <a:defRPr sz="2200">
-                <a:solidFill>
-                  <a:srgbClr val="444444"/>
-                </a:solidFill>
-              </a:defRPr>
-            </a:pPr>
-            <a:r>
-              <a:t>4. Ładowanie jądra SO i sterowników</a:t>
-            </a:r>
-          </a:p>
-          <a:p>
-            <a:pPr>
-              <a:spcAft>
-                <a:spcPts val="1000"/>
-              </a:spcAft>
-              <a:defRPr sz="2200">
-                <a:solidFill>
-                  <a:srgbClr val="444444"/>
-                </a:solidFill>
-              </a:defRPr>
-            </a:pPr>
-            <a:r>
-              <a:t>5. Usługi użytkownika — logowanie, pulpit</a:t>
+                <a:spcPts val="800"/>
+              </a:spcAft>
+              <a:defRPr sz="1900">
+                <a:solidFill>
+                  <a:srgbClr val="333333"/>
+                </a:solidFill>
+              </a:defRPr>
+            </a:pPr>
+            <a:r>
+              <a:t>I/O: kontrolery + rejestry; polling / przerwania / DMA; sterowniki i kolejki w SO.</a:t>
+            </a:r>
+          </a:p>
+          <a:p>
+            <a:pPr>
+              <a:spcAft>
+                <a:spcPts val="800"/>
+              </a:spcAft>
+              <a:defRPr sz="1900">
+                <a:solidFill>
+                  <a:srgbClr val="333333"/>
+                </a:solidFill>
+              </a:defRPr>
+            </a:pPr>
+            <a:r>
+              <a:t>Magistrale: adres, dane, sterowanie; ewolucja od PCI do PCIe (pakiety, lane, punkt–punkt).</a:t>
+            </a:r>
+          </a:p>
+          <a:p>
+            <a:pPr>
+              <a:spcAft>
+                <a:spcPts val="800"/>
+              </a:spcAft>
+              <a:defRPr sz="1900">
+                <a:solidFill>
+                  <a:srgbClr val="333333"/>
+                </a:solidFill>
+              </a:defRPr>
+            </a:pPr>
+            <a:r>
+              <a:t>Boot: POST → BIOS/UEFI → bootloader → jądro → init użytkownika.</a:t>
+            </a:r>
+          </a:p>
+          <a:p>
+            <a:pPr>
+              <a:spcAft>
+                <a:spcPts val="800"/>
+              </a:spcAft>
+              <a:defRPr sz="1900">
+                <a:solidFill>
+                  <a:srgbClr val="333333"/>
+                </a:solidFill>
+              </a:defRPr>
+            </a:pPr>
+            <a:r>
+              <a:t>Te trzy tematy łączą sprzęt z tym, co studiujesz w SO: urządzenia, wydajność I/O i moment, w którym OS przejmuje maszynę.</a:t>
             </a:r>
           </a:p>
         </p:txBody>
@@ -4076,7 +5775,7 @@
 </p:sld>
 </file>
 
-<file path=ppt/slides/slide14.xml><?xml version="1.0" encoding="utf-8"?>
+<file path=ppt/slides/slide22.xml><?xml version="1.0" encoding="utf-8"?>
 <p:sld xmlns:a="http://schemas.openxmlformats.org/drawingml/2006/main" xmlns:p="http://schemas.openxmlformats.org/presentationml/2006/main" xmlns:r="http://schemas.openxmlformats.org/officeDocument/2006/relationships">
   <p:cSld>
     <p:spTree>
@@ -4094,8 +5793,8 @@
         </p:nvSpPr>
         <p:spPr>
           <a:xfrm>
-            <a:off x="548640" y="411480"/>
-            <a:ext cx="11064240" cy="822960"/>
+            <a:off x="502920" y="320040"/>
+            <a:ext cx="11155680" cy="777240"/>
           </a:xfrm>
           <a:prstGeom prst="rect">
             <a:avLst/>
@@ -4109,14 +5808,14 @@
           <a:lstStyle/>
           <a:p>
             <a:pPr>
-              <a:defRPr sz="3200" b="1">
+              <a:defRPr sz="2800" b="1">
                 <a:solidFill>
                   <a:srgbClr val="1A365D"/>
                 </a:solidFill>
               </a:defRPr>
             </a:pPr>
             <a:r>
-              <a:t>MBR i GPT</a:t>
+              <a:t>Bibliografia i źródła</a:t>
             </a:r>
           </a:p>
         </p:txBody>
@@ -4129,8 +5828,8 @@
         </p:nvSpPr>
         <p:spPr>
           <a:xfrm>
-            <a:off x="731520" y="1371600"/>
-            <a:ext cx="10789920" cy="5029200"/>
+            <a:off x="594360" y="1143000"/>
+            <a:ext cx="10972800" cy="5394960"/>
           </a:xfrm>
           <a:prstGeom prst="rect">
             <a:avLst/>
@@ -4145,46 +5844,121 @@
           <a:p>
             <a:pPr>
               <a:spcAft>
-                <a:spcPts val="1000"/>
-              </a:spcAft>
-              <a:defRPr sz="2200">
-                <a:solidFill>
-                  <a:srgbClr val="444444"/>
-                </a:solidFill>
-              </a:defRPr>
-            </a:pPr>
-            <a:r>
-              <a:t>MBR: pierwszy sektor dysku (512 B), limit 2 TB</a:t>
-            </a:r>
-          </a:p>
-          <a:p>
-            <a:pPr>
-              <a:spcAft>
-                <a:spcPts val="1000"/>
-              </a:spcAft>
-              <a:defRPr sz="2200">
-                <a:solidFill>
-                  <a:srgbClr val="444444"/>
-                </a:solidFill>
-              </a:defRPr>
-            </a:pPr>
-            <a:r>
-              <a:t>GPT: duże dyski, standard przy UEFI</a:t>
-            </a:r>
-          </a:p>
-          <a:p>
-            <a:pPr>
-              <a:spcAft>
-                <a:spcPts val="1000"/>
-              </a:spcAft>
-              <a:defRPr sz="2200">
-                <a:solidFill>
-                  <a:srgbClr val="444444"/>
-                </a:solidFill>
-              </a:defRPr>
-            </a:pPr>
-            <a:r>
-              <a:t>Po załadowaniu jądra SO przejmuje procesy, pamięć i I/O</a:t>
+                <a:spcPts val="800"/>
+              </a:spcAft>
+              <a:defRPr sz="1500">
+                <a:solidFill>
+                  <a:srgbClr val="333333"/>
+                </a:solidFill>
+              </a:defRPr>
+            </a:pPr>
+            <a:r>
+              <a:t>Silberschatz A., Galvin P. B., Gagne G., Systemy operacyjne, Wydanie V, PWN — urządzenia I/O, struktura systemu.</a:t>
+            </a:r>
+          </a:p>
+          <a:p>
+            <a:pPr>
+              <a:spcAft>
+                <a:spcPts val="800"/>
+              </a:spcAft>
+              <a:defRPr sz="1500">
+                <a:solidFill>
+                  <a:srgbClr val="333333"/>
+                </a:solidFill>
+              </a:defRPr>
+            </a:pPr>
+            <a:r>
+              <a:t>Arpaci-Dusseau R., Arpaci-Dusseau A., Operating Systems: Three Easy Pieces (OSTEP), rozdz. o urządzeniach i I/O — https://pages.cs.wisc.edu/~remzi/OSTEP/</a:t>
+            </a:r>
+          </a:p>
+          <a:p>
+            <a:pPr>
+              <a:spcAft>
+                <a:spcPts val="800"/>
+              </a:spcAft>
+              <a:defRPr sz="1500">
+                <a:solidFill>
+                  <a:srgbClr val="333333"/>
+                </a:solidFill>
+              </a:defRPr>
+            </a:pPr>
+            <a:r>
+              <a:t>Cambridge University, Operating Systems — I/O Subsystems (materiały wykładowe) — https://www.cl.cam.ac.uk/teaching/2425/OpSystems/</a:t>
+            </a:r>
+          </a:p>
+          <a:p>
+            <a:pPr>
+              <a:spcAft>
+                <a:spcPts val="800"/>
+              </a:spcAft>
+              <a:defRPr sz="1500">
+                <a:solidFill>
+                  <a:srgbClr val="333333"/>
+                </a:solidFill>
+              </a:defRPr>
+            </a:pPr>
+            <a:r>
+              <a:t>Cornell CS 4410, Devices and I/O — https://www.cs.cornell.edu/courses/cs4410/</a:t>
+            </a:r>
+          </a:p>
+          <a:p>
+            <a:pPr>
+              <a:spcAft>
+                <a:spcPts val="800"/>
+              </a:spcAft>
+              <a:defRPr sz="1500">
+                <a:solidFill>
+                  <a:srgbClr val="333333"/>
+                </a:solidFill>
+              </a:defRPr>
+            </a:pPr>
+            <a:r>
+              <a:t>Arch boot process, ArchWiki — https://wiki.archlinux.org/title/Arch_boot_process</a:t>
+            </a:r>
+          </a:p>
+          <a:p>
+            <a:pPr>
+              <a:spcAft>
+                <a:spcPts val="800"/>
+              </a:spcAft>
+              <a:defRPr sz="1500">
+                <a:solidFill>
+                  <a:srgbClr val="333333"/>
+                </a:solidFill>
+              </a:defRPr>
+            </a:pPr>
+            <a:r>
+              <a:t>Red Hat, Boot, Init and Shutdown (RHEL documentation) — https://docs.redhat.com/</a:t>
+            </a:r>
+          </a:p>
+          <a:p>
+            <a:pPr>
+              <a:spcAft>
+                <a:spcPts val="800"/>
+              </a:spcAft>
+              <a:defRPr sz="1500">
+                <a:solidFill>
+                  <a:srgbClr val="333333"/>
+                </a:solidFill>
+              </a:defRPr>
+            </a:pPr>
+            <a:r>
+              <a:t>UEFI Forum, UEFI Specification — Boot Services / ExitBootServices — https://uefi.org/specifications</a:t>
+            </a:r>
+          </a:p>
+          <a:p>
+            <a:pPr>
+              <a:spcAft>
+                <a:spcPts val="800"/>
+              </a:spcAft>
+              <a:defRPr sz="1500">
+                <a:solidFill>
+                  <a:srgbClr val="333333"/>
+                </a:solidFill>
+              </a:defRPr>
+            </a:pPr>
+            <a:r>
+              <a:t>Computer Internals, PCI and PCI Express — https://www.computerinternals.app/</a:t>
             </a:r>
           </a:p>
         </p:txBody>
@@ -4197,7 +5971,7 @@
 </p:sld>
 </file>
 
-<file path=ppt/slides/slide15.xml><?xml version="1.0" encoding="utf-8"?>
+<file path=ppt/slides/slide23.xml><?xml version="1.0" encoding="utf-8"?>
 <p:sld xmlns:a="http://schemas.openxmlformats.org/drawingml/2006/main" xmlns:p="http://schemas.openxmlformats.org/presentationml/2006/main" xmlns:r="http://schemas.openxmlformats.org/officeDocument/2006/relationships">
   <p:cSld>
     <p:spTree>
@@ -4215,8 +5989,8 @@
         </p:nvSpPr>
         <p:spPr>
           <a:xfrm>
-            <a:off x="548640" y="411480"/>
-            <a:ext cx="11064240" cy="822960"/>
+            <a:off x="640080" y="1828800"/>
+            <a:ext cx="10972800" cy="2743200"/>
           </a:xfrm>
           <a:prstGeom prst="rect">
             <a:avLst/>
@@ -4224,240 +5998,13 @@
           <a:noFill/>
         </p:spPr>
         <p:txBody>
-          <a:bodyPr wrap="none">
-            <a:spAutoFit/>
-          </a:bodyPr>
-          <a:lstStyle/>
-          <a:p>
-            <a:pPr>
-              <a:defRPr sz="3200" b="1">
-                <a:solidFill>
-                  <a:srgbClr val="1A365D"/>
-                </a:solidFill>
-              </a:defRPr>
-            </a:pPr>
-            <a:r>
-              <a:t>Podsumowanie</a:t>
-            </a:r>
-          </a:p>
-        </p:txBody>
-      </p:sp>
-      <p:sp>
-        <p:nvSpPr>
-          <p:cNvPr id="3" name="TextBox 2"/>
-          <p:cNvSpPr txBox="1"/>
-          <p:nvPr/>
-        </p:nvSpPr>
-        <p:spPr>
-          <a:xfrm>
-            <a:off x="731520" y="1371600"/>
-            <a:ext cx="10789920" cy="5029200"/>
-          </a:xfrm>
-          <a:prstGeom prst="rect">
-            <a:avLst/>
-          </a:prstGeom>
-          <a:noFill/>
-        </p:spPr>
-        <p:txBody>
           <a:bodyPr wrap="square">
             <a:spAutoFit/>
           </a:bodyPr>
           <a:lstStyle/>
           <a:p>
-            <a:pPr>
-              <a:spcAft>
-                <a:spcPts val="1000"/>
-              </a:spcAft>
-              <a:defRPr sz="2200">
-                <a:solidFill>
-                  <a:srgbClr val="444444"/>
-                </a:solidFill>
-              </a:defRPr>
-            </a:pPr>
-            <a:r>
-              <a:t>I/O: sterowniki; polling, przerwania, DMA</a:t>
-            </a:r>
-          </a:p>
-          <a:p>
-            <a:pPr>
-              <a:spcAft>
-                <a:spcPts val="1000"/>
-              </a:spcAft>
-              <a:defRPr sz="2200">
-                <a:solidFill>
-                  <a:srgbClr val="444444"/>
-                </a:solidFill>
-              </a:defRPr>
-            </a:pPr>
-            <a:r>
-              <a:t>Magistrale: adres, dane, sterowanie; PCIe / USB / SATA</a:t>
-            </a:r>
-          </a:p>
-          <a:p>
-            <a:pPr>
-              <a:spcAft>
-                <a:spcPts val="1000"/>
-              </a:spcAft>
-              <a:defRPr sz="2200">
-                <a:solidFill>
-                  <a:srgbClr val="444444"/>
-                </a:solidFill>
-              </a:defRPr>
-            </a:pPr>
-            <a:r>
-              <a:t>Start: POST → firmware → bootloader → jądro SO</a:t>
-            </a:r>
-          </a:p>
-        </p:txBody>
-      </p:sp>
-    </p:spTree>
-  </p:cSld>
-  <p:clrMapOvr>
-    <a:masterClrMapping/>
-  </p:clrMapOvr>
-</p:sld>
-</file>
-
-<file path=ppt/slides/slide16.xml><?xml version="1.0" encoding="utf-8"?>
-<p:sld xmlns:a="http://schemas.openxmlformats.org/drawingml/2006/main" xmlns:p="http://schemas.openxmlformats.org/presentationml/2006/main" xmlns:r="http://schemas.openxmlformats.org/officeDocument/2006/relationships">
-  <p:cSld>
-    <p:spTree>
-      <p:nvGrpSpPr>
-        <p:cNvPr id="1" name=""/>
-        <p:cNvGrpSpPr/>
-        <p:nvPr/>
-      </p:nvGrpSpPr>
-      <p:grpSpPr/>
-      <p:sp>
-        <p:nvSpPr>
-          <p:cNvPr id="2" name="TextBox 1"/>
-          <p:cNvSpPr txBox="1"/>
-          <p:nvPr/>
-        </p:nvSpPr>
-        <p:spPr>
-          <a:xfrm>
-            <a:off x="548640" y="411480"/>
-            <a:ext cx="11064240" cy="822960"/>
-          </a:xfrm>
-          <a:prstGeom prst="rect">
-            <a:avLst/>
-          </a:prstGeom>
-          <a:noFill/>
-        </p:spPr>
-        <p:txBody>
-          <a:bodyPr wrap="none">
-            <a:spAutoFit/>
-          </a:bodyPr>
-          <a:lstStyle/>
-          <a:p>
-            <a:pPr>
-              <a:defRPr sz="3200" b="1">
-                <a:solidFill>
-                  <a:srgbClr val="1A365D"/>
-                </a:solidFill>
-              </a:defRPr>
-            </a:pPr>
-            <a:r>
-              <a:t>Źródła</a:t>
-            </a:r>
-          </a:p>
-        </p:txBody>
-      </p:sp>
-      <p:sp>
-        <p:nvSpPr>
-          <p:cNvPr id="3" name="TextBox 2"/>
-          <p:cNvSpPr txBox="1"/>
-          <p:nvPr/>
-        </p:nvSpPr>
-        <p:spPr>
-          <a:xfrm>
-            <a:off x="731520" y="1371600"/>
-            <a:ext cx="10789920" cy="5029200"/>
-          </a:xfrm>
-          <a:prstGeom prst="rect">
-            <a:avLst/>
-          </a:prstGeom>
-          <a:noFill/>
-        </p:spPr>
-        <p:txBody>
-          <a:bodyPr wrap="square">
-            <a:spAutoFit/>
-          </a:bodyPr>
-          <a:lstStyle/>
-          <a:p>
-            <a:pPr>
-              <a:spcAft>
-                <a:spcPts val="1000"/>
-              </a:spcAft>
-              <a:defRPr sz="2200">
-                <a:solidFill>
-                  <a:srgbClr val="444444"/>
-                </a:solidFill>
-              </a:defRPr>
-            </a:pPr>
-            <a:r>
-              <a:t>Materiał PDF: Architektura komputerów — I/O, magistrale i booting</a:t>
-            </a:r>
-          </a:p>
-          <a:p>
-            <a:pPr>
-              <a:spcAft>
-                <a:spcPts val="1000"/>
-              </a:spcAft>
-              <a:defRPr sz="2200">
-                <a:solidFill>
-                  <a:srgbClr val="444444"/>
-                </a:solidFill>
-              </a:defRPr>
-            </a:pPr>
-            <a:r>
-              <a:t>A. Silberschatz, P. B. Galvin, G. Gagne — Systemy operacyjne, Wydanie V, PWN</a:t>
-            </a:r>
-          </a:p>
-        </p:txBody>
-      </p:sp>
-    </p:spTree>
-  </p:cSld>
-  <p:clrMapOvr>
-    <a:masterClrMapping/>
-  </p:clrMapOvr>
-</p:sld>
-</file>
-
-<file path=ppt/slides/slide17.xml><?xml version="1.0" encoding="utf-8"?>
-<p:sld xmlns:a="http://schemas.openxmlformats.org/drawingml/2006/main" xmlns:p="http://schemas.openxmlformats.org/presentationml/2006/main" xmlns:r="http://schemas.openxmlformats.org/officeDocument/2006/relationships">
-  <p:cSld>
-    <p:spTree>
-      <p:nvGrpSpPr>
-        <p:cNvPr id="1" name=""/>
-        <p:cNvGrpSpPr/>
-        <p:nvPr/>
-      </p:nvGrpSpPr>
-      <p:grpSpPr/>
-      <p:sp>
-        <p:nvSpPr>
-          <p:cNvPr id="2" name="TextBox 1"/>
-          <p:cNvSpPr txBox="1"/>
-          <p:nvPr/>
-        </p:nvSpPr>
-        <p:spPr>
-          <a:xfrm>
-            <a:off x="731520" y="2011680"/>
-            <a:ext cx="10698480" cy="1828800"/>
-          </a:xfrm>
-          <a:prstGeom prst="rect">
-            <a:avLst/>
-          </a:prstGeom>
-          <a:noFill/>
-        </p:spPr>
-        <p:txBody>
-          <a:bodyPr wrap="square">
-            <a:spAutoFit/>
-          </a:bodyPr>
-          <a:lstStyle/>
-          <a:p>
             <a:pPr algn="ctr">
-              <a:defRPr sz="4000" b="1">
+              <a:defRPr sz="3600" b="1">
                 <a:solidFill>
                   <a:srgbClr val="1A365D"/>
                 </a:solidFill>
@@ -4470,137 +6017,16 @@
           <a:p>
             <a:pPr algn="ctr">
               <a:spcBef>
-                <a:spcPts val="1800"/>
+                <a:spcPts val="1600"/>
               </a:spcBef>
-              <a:defRPr sz="2200">
-                <a:solidFill>
-                  <a:srgbClr val="444444"/>
+              <a:defRPr sz="2000">
+                <a:solidFill>
+                  <a:srgbClr val="555555"/>
                 </a:solidFill>
               </a:defRPr>
             </a:pPr>
             <a:r>
               <a:t>Pytania?</a:t>
-            </a:r>
-          </a:p>
-        </p:txBody>
-      </p:sp>
-    </p:spTree>
-  </p:cSld>
-  <p:clrMapOvr>
-    <a:masterClrMapping/>
-  </p:clrMapOvr>
-</p:sld>
-</file>
-
-<file path=ppt/slides/slide2.xml><?xml version="1.0" encoding="utf-8"?>
-<p:sld xmlns:a="http://schemas.openxmlformats.org/drawingml/2006/main" xmlns:p="http://schemas.openxmlformats.org/presentationml/2006/main" xmlns:r="http://schemas.openxmlformats.org/officeDocument/2006/relationships">
-  <p:cSld>
-    <p:spTree>
-      <p:nvGrpSpPr>
-        <p:cNvPr id="1" name=""/>
-        <p:cNvGrpSpPr/>
-        <p:nvPr/>
-      </p:nvGrpSpPr>
-      <p:grpSpPr/>
-      <p:sp>
-        <p:nvSpPr>
-          <p:cNvPr id="2" name="TextBox 1"/>
-          <p:cNvSpPr txBox="1"/>
-          <p:nvPr/>
-        </p:nvSpPr>
-        <p:spPr>
-          <a:xfrm>
-            <a:off x="548640" y="411480"/>
-            <a:ext cx="11064240" cy="822960"/>
-          </a:xfrm>
-          <a:prstGeom prst="rect">
-            <a:avLst/>
-          </a:prstGeom>
-          <a:noFill/>
-        </p:spPr>
-        <p:txBody>
-          <a:bodyPr wrap="none">
-            <a:spAutoFit/>
-          </a:bodyPr>
-          <a:lstStyle/>
-          <a:p>
-            <a:pPr>
-              <a:defRPr sz="3200" b="1">
-                <a:solidFill>
-                  <a:srgbClr val="1A365D"/>
-                </a:solidFill>
-              </a:defRPr>
-            </a:pPr>
-            <a:r>
-              <a:t>Plan prezentacji</a:t>
-            </a:r>
-          </a:p>
-        </p:txBody>
-      </p:sp>
-      <p:sp>
-        <p:nvSpPr>
-          <p:cNvPr id="3" name="TextBox 2"/>
-          <p:cNvSpPr txBox="1"/>
-          <p:nvPr/>
-        </p:nvSpPr>
-        <p:spPr>
-          <a:xfrm>
-            <a:off x="731520" y="1371600"/>
-            <a:ext cx="10789920" cy="5029200"/>
-          </a:xfrm>
-          <a:prstGeom prst="rect">
-            <a:avLst/>
-          </a:prstGeom>
-          <a:noFill/>
-        </p:spPr>
-        <p:txBody>
-          <a:bodyPr wrap="square">
-            <a:spAutoFit/>
-          </a:bodyPr>
-          <a:lstStyle/>
-          <a:p>
-            <a:pPr>
-              <a:spcAft>
-                <a:spcPts val="1000"/>
-              </a:spcAft>
-              <a:defRPr sz="2200">
-                <a:solidFill>
-                  <a:srgbClr val="444444"/>
-                </a:solidFill>
-              </a:defRPr>
-            </a:pPr>
-            <a:r>
-              <a:t>Urządzenia wejścia-wyjścia — współpraca CPU ze sprzętem</a:t>
-            </a:r>
-          </a:p>
-          <a:p>
-            <a:pPr>
-              <a:spcAft>
-                <a:spcPts val="1000"/>
-              </a:spcAft>
-              <a:defRPr sz="2200">
-                <a:solidFill>
-                  <a:srgbClr val="444444"/>
-                </a:solidFill>
-              </a:defRPr>
-            </a:pPr>
-            <a:r>
-              <a:t>Magistrale — łącza w systemie komputerowym</a:t>
-            </a:r>
-          </a:p>
-          <a:p>
-            <a:pPr>
-              <a:spcAft>
-                <a:spcPts val="1000"/>
-              </a:spcAft>
-              <a:defRPr sz="2200">
-                <a:solidFill>
-                  <a:srgbClr val="444444"/>
-                </a:solidFill>
-              </a:defRPr>
-            </a:pPr>
-            <a:r>
-              <a:t>Uruchamianie komputera — od zasilania do jądra SO</a:t>
             </a:r>
           </a:p>
         </p:txBody>
@@ -4631,8 +6057,8 @@
         </p:nvSpPr>
         <p:spPr>
           <a:xfrm>
-            <a:off x="548640" y="411480"/>
-            <a:ext cx="11064240" cy="822960"/>
+            <a:off x="502920" y="320040"/>
+            <a:ext cx="11155680" cy="777240"/>
           </a:xfrm>
           <a:prstGeom prst="rect">
             <a:avLst/>
@@ -4646,14 +6072,14 @@
           <a:lstStyle/>
           <a:p>
             <a:pPr>
-              <a:defRPr sz="3200" b="1">
+              <a:defRPr sz="2800" b="1">
                 <a:solidFill>
                   <a:srgbClr val="1A365D"/>
                 </a:solidFill>
               </a:defRPr>
             </a:pPr>
             <a:r>
-              <a:t>Urządzenia wejścia-wyjścia (I/O)</a:t>
+              <a:t>Urządzenia I/O — po co systemowi operacyjnemu?</a:t>
             </a:r>
           </a:p>
         </p:txBody>
@@ -4666,8 +6092,8 @@
         </p:nvSpPr>
         <p:spPr>
           <a:xfrm>
-            <a:off x="731520" y="1371600"/>
-            <a:ext cx="10789920" cy="5029200"/>
+            <a:off x="594360" y="1143000"/>
+            <a:ext cx="10972800" cy="5394960"/>
           </a:xfrm>
           <a:prstGeom prst="rect">
             <a:avLst/>
@@ -4682,61 +6108,61 @@
           <a:p>
             <a:pPr>
               <a:spcAft>
-                <a:spcPts val="1000"/>
-              </a:spcAft>
-              <a:defRPr sz="2200">
-                <a:solidFill>
-                  <a:srgbClr val="444444"/>
-                </a:solidFill>
-              </a:defRPr>
-            </a:pPr>
-            <a:r>
-              <a:t>Urządzenia zewnętrzne: klawiatura, dysk, sieć, drukarka…</a:t>
-            </a:r>
-          </a:p>
-          <a:p>
-            <a:pPr>
-              <a:spcAft>
-                <a:spcPts val="1000"/>
-              </a:spcAft>
-              <a:defRPr sz="2200">
-                <a:solidFill>
-                  <a:srgbClr val="444444"/>
-                </a:solidFill>
-              </a:defRPr>
-            </a:pPr>
-            <a:r>
-              <a:t>CPU komunikuje się przez sterownik urządzenia (kontroler):</a:t>
-            </a:r>
-          </a:p>
-          <a:p>
-            <a:pPr lvl="1">
-              <a:spcAft>
-                <a:spcPts val="1000"/>
-              </a:spcAft>
-              <a:defRPr sz="2200">
-                <a:solidFill>
-                  <a:srgbClr val="444444"/>
-                </a:solidFill>
-              </a:defRPr>
-            </a:pPr>
-            <a:r>
-              <a:t>  rejestry stanu i sterowania, bufor lokalny</a:t>
-            </a:r>
-          </a:p>
-          <a:p>
-            <a:pPr>
-              <a:spcAft>
-                <a:spcPts val="1000"/>
-              </a:spcAft>
-              <a:defRPr sz="2200">
-                <a:solidFill>
-                  <a:srgbClr val="444444"/>
-                </a:solidFill>
-              </a:defRPr>
-            </a:pPr>
-            <a:r>
-              <a:t>System operacyjny udostępnia urządzenia przez sterowniki i abstrakcje (pliki, gniazda)</a:t>
+                <a:spcPts val="800"/>
+              </a:spcAft>
+              <a:defRPr sz="1900">
+                <a:solidFill>
+                  <a:srgbClr val="333333"/>
+                </a:solidFill>
+              </a:defRPr>
+            </a:pPr>
+            <a:r>
+              <a:t>Programy użytkownika nie mówią bezpośrednio z dyskiem czy kartą sieciową — wołają system operacyjny (np. read(), write()).</a:t>
+            </a:r>
+          </a:p>
+          <a:p>
+            <a:pPr>
+              <a:spcAft>
+                <a:spcPts val="800"/>
+              </a:spcAft>
+              <a:defRPr sz="1900">
+                <a:solidFill>
+                  <a:srgbClr val="333333"/>
+                </a:solidFill>
+              </a:defRPr>
+            </a:pPr>
+            <a:r>
+              <a:t>SO ukrywa różnorodność sprzętu: ten sam interfejs pliku może stać za dyskiem SSD, pendrivem USB albo siecią.</a:t>
+            </a:r>
+          </a:p>
+          <a:p>
+            <a:pPr>
+              <a:spcAft>
+                <a:spcPts val="800"/>
+              </a:spcAft>
+              <a:defRPr sz="1900">
+                <a:solidFill>
+                  <a:srgbClr val="333333"/>
+                </a:solidFill>
+              </a:defRPr>
+            </a:pPr>
+            <a:r>
+              <a:t>Urządzenia są wolniejsze niż CPU i RAM — stąd cała architektura I/O: buforowanie, przerwania, DMA, kolejki.</a:t>
+            </a:r>
+          </a:p>
+          <a:p>
+            <a:pPr>
+              <a:spcAft>
+                <a:spcPts val="800"/>
+              </a:spcAft>
+              <a:defRPr sz="1900">
+                <a:solidFill>
+                  <a:srgbClr val="333333"/>
+                </a:solidFill>
+              </a:defRPr>
+            </a:pPr>
+            <a:r>
+              <a:t>Każde urządzenie ma kontroler (sterownik sprzętowy): logika, która wykonuje rozkazy procesora i zarządza samym urządzeniem.</a:t>
             </a:r>
           </a:p>
         </p:txBody>
@@ -4767,8 +6193,8 @@
         </p:nvSpPr>
         <p:spPr>
           <a:xfrm>
-            <a:off x="548640" y="411480"/>
-            <a:ext cx="11064240" cy="822960"/>
+            <a:off x="502920" y="320040"/>
+            <a:ext cx="11155680" cy="777240"/>
           </a:xfrm>
           <a:prstGeom prst="rect">
             <a:avLst/>
@@ -4782,14 +6208,603 @@
           <a:lstStyle/>
           <a:p>
             <a:pPr>
-              <a:defRPr sz="3000" b="1">
+              <a:defRPr sz="2800" b="1">
                 <a:solidFill>
                   <a:srgbClr val="1A365D"/>
                 </a:solidFill>
               </a:defRPr>
             </a:pPr>
             <a:r>
-              <a:t>Metody transferu danych I/O</a:t>
+              <a:t>Kontroler urządzenia i rejestry</a:t>
+            </a:r>
+          </a:p>
+        </p:txBody>
+      </p:sp>
+      <p:sp>
+        <p:nvSpPr>
+          <p:cNvPr id="3" name="TextBox 2"/>
+          <p:cNvSpPr txBox="1"/>
+          <p:nvPr/>
+        </p:nvSpPr>
+        <p:spPr>
+          <a:xfrm>
+            <a:off x="594360" y="1143000"/>
+            <a:ext cx="10972800" cy="5394960"/>
+          </a:xfrm>
+          <a:prstGeom prst="rect">
+            <a:avLst/>
+          </a:prstGeom>
+          <a:noFill/>
+        </p:spPr>
+        <p:txBody>
+          <a:bodyPr wrap="square">
+            <a:spAutoFit/>
+          </a:bodyPr>
+          <a:lstStyle/>
+          <a:p>
+            <a:pPr>
+              <a:spcAft>
+                <a:spcPts val="800"/>
+              </a:spcAft>
+              <a:defRPr sz="1900">
+                <a:solidFill>
+                  <a:srgbClr val="333333"/>
+                </a:solidFill>
+              </a:defRPr>
+            </a:pPr>
+            <a:r>
+              <a:t>Typowy interfejs (uproszczony): rejestr stanu (status), rejestr poleceń (command), rejestr danych (data).</a:t>
+            </a:r>
+          </a:p>
+          <a:p>
+            <a:pPr>
+              <a:spcAft>
+                <a:spcPts val="800"/>
+              </a:spcAft>
+              <a:defRPr sz="1900">
+                <a:solidFill>
+                  <a:srgbClr val="333333"/>
+                </a:solidFill>
+              </a:defRPr>
+            </a:pPr>
+            <a:r>
+              <a:t>OS (lub jądro) zapisuje polecenie, ewentualnie dane, a potem czeka na sygnał „gotowe” w rejestrze stanu.</a:t>
+            </a:r>
+          </a:p>
+          <a:p>
+            <a:pPr>
+              <a:spcAft>
+                <a:spcPts val="800"/>
+              </a:spcAft>
+              <a:defRPr sz="1900">
+                <a:solidFill>
+                  <a:srgbClr val="333333"/>
+                </a:solidFill>
+              </a:defRPr>
+            </a:pPr>
+            <a:r>
+              <a:t>Komunikacja odbywa się przez magistralę — te same linie łączą CPU z pamięcią i kontrolerami.</a:t>
+            </a:r>
+          </a:p>
+          <a:p>
+            <a:pPr>
+              <a:spcAft>
+                <a:spcPts val="800"/>
+              </a:spcAft>
+              <a:defRPr sz="1900">
+                <a:solidFill>
+                  <a:srgbClr val="333333"/>
+                </a:solidFill>
+              </a:defRPr>
+            </a:pPr>
+            <a:r>
+              <a:t>Dwa modele adresowania: port I/O (osobna przestrzeń portów) lub memory-mapped I/O (odczyt/zapis pod „adresem” urządzenia w mapie pamięci).</a:t>
+            </a:r>
+          </a:p>
+        </p:txBody>
+      </p:sp>
+    </p:spTree>
+  </p:cSld>
+  <p:clrMapOvr>
+    <a:masterClrMapping/>
+  </p:clrMapOvr>
+</p:sld>
+</file>
+
+<file path=ppt/slides/slide5.xml><?xml version="1.0" encoding="utf-8"?>
+<p:sld xmlns:a="http://schemas.openxmlformats.org/drawingml/2006/main" xmlns:p="http://schemas.openxmlformats.org/presentationml/2006/main" xmlns:r="http://schemas.openxmlformats.org/officeDocument/2006/relationships">
+  <p:cSld>
+    <p:spTree>
+      <p:nvGrpSpPr>
+        <p:cNvPr id="1" name=""/>
+        <p:cNvGrpSpPr/>
+        <p:nvPr/>
+      </p:nvGrpSpPr>
+      <p:grpSpPr/>
+      <p:sp>
+        <p:nvSpPr>
+          <p:cNvPr id="2" name="TextBox 1"/>
+          <p:cNvSpPr txBox="1"/>
+          <p:nvPr/>
+        </p:nvSpPr>
+        <p:spPr>
+          <a:xfrm>
+            <a:off x="502920" y="320040"/>
+            <a:ext cx="11155680" cy="777240"/>
+          </a:xfrm>
+          <a:prstGeom prst="rect">
+            <a:avLst/>
+          </a:prstGeom>
+          <a:noFill/>
+        </p:spPr>
+        <p:txBody>
+          <a:bodyPr wrap="none">
+            <a:spAutoFit/>
+          </a:bodyPr>
+          <a:lstStyle/>
+          <a:p>
+            <a:pPr>
+              <a:defRPr sz="2800" b="1">
+                <a:solidFill>
+                  <a:srgbClr val="1A365D"/>
+                </a:solidFill>
+              </a:defRPr>
+            </a:pPr>
+            <a:r>
+              <a:t>Odpytywanie (polling)</a:t>
+            </a:r>
+          </a:p>
+        </p:txBody>
+      </p:sp>
+      <p:sp>
+        <p:nvSpPr>
+          <p:cNvPr id="3" name="TextBox 2"/>
+          <p:cNvSpPr txBox="1"/>
+          <p:nvPr/>
+        </p:nvSpPr>
+        <p:spPr>
+          <a:xfrm>
+            <a:off x="594360" y="1143000"/>
+            <a:ext cx="10972800" cy="5394960"/>
+          </a:xfrm>
+          <a:prstGeom prst="rect">
+            <a:avLst/>
+          </a:prstGeom>
+          <a:noFill/>
+        </p:spPr>
+        <p:txBody>
+          <a:bodyPr wrap="square">
+            <a:spAutoFit/>
+          </a:bodyPr>
+          <a:lstStyle/>
+          <a:p>
+            <a:pPr>
+              <a:spcAft>
+                <a:spcPts val="800"/>
+              </a:spcAft>
+              <a:defRPr sz="1900">
+                <a:solidFill>
+                  <a:srgbClr val="333333"/>
+                </a:solidFill>
+              </a:defRPr>
+            </a:pPr>
+            <a:r>
+              <a:t>Procesor w pętli odczytuje rejestr stanu: „czy urządzenie skończyło?” — to aktywne czekanie (busy-wait).</a:t>
+            </a:r>
+          </a:p>
+          <a:p>
+            <a:pPr>
+              <a:spcAft>
+                <a:spcPts val="800"/>
+              </a:spcAft>
+              <a:defRPr sz="1900">
+                <a:solidFill>
+                  <a:srgbClr val="333333"/>
+                </a:solidFill>
+              </a:defRPr>
+            </a:pPr>
+            <a:r>
+              <a:t>Schemat: start operacji → while (STATUS == BUSY) → odczyt wyniku → powrót do aplikacji.</a:t>
+            </a:r>
+          </a:p>
+          <a:p>
+            <a:pPr>
+              <a:spcAft>
+                <a:spcPts val="800"/>
+              </a:spcAft>
+              <a:defRPr sz="1900">
+                <a:solidFill>
+                  <a:srgbClr val="333333"/>
+                </a:solidFill>
+              </a:defRPr>
+            </a:pPr>
+            <a:r>
+              <a:t>Zalety: prostota implementacji, przewidywalność — czasem w embedded lub bardzo szybkich urządzeniach.</a:t>
+            </a:r>
+          </a:p>
+          <a:p>
+            <a:pPr>
+              <a:spcAft>
+                <a:spcPts val="800"/>
+              </a:spcAft>
+              <a:defRPr sz="1900">
+                <a:solidFill>
+                  <a:srgbClr val="333333"/>
+                </a:solidFill>
+              </a:defRPr>
+            </a:pPr>
+            <a:r>
+              <a:t>Wady: marnowanie cykli CPU; ryzyko opóźnień lub utraty danych, jeśli CPU zajmie się czymś innym zbyt długo.</a:t>
+            </a:r>
+          </a:p>
+          <a:p>
+            <a:pPr>
+              <a:spcAft>
+                <a:spcPts val="800"/>
+              </a:spcAft>
+              <a:defRPr sz="1900">
+                <a:solidFill>
+                  <a:srgbClr val="333333"/>
+                </a:solidFill>
+              </a:defRPr>
+            </a:pPr>
+            <a:r>
+              <a:t>Dla wolnych urządzeń (drukarka, dysk) polling jest mało efektywny — stąd przerwania i DMA.</a:t>
+            </a:r>
+          </a:p>
+        </p:txBody>
+      </p:sp>
+    </p:spTree>
+  </p:cSld>
+  <p:clrMapOvr>
+    <a:masterClrMapping/>
+  </p:clrMapOvr>
+</p:sld>
+</file>
+
+<file path=ppt/slides/slide6.xml><?xml version="1.0" encoding="utf-8"?>
+<p:sld xmlns:a="http://schemas.openxmlformats.org/drawingml/2006/main" xmlns:p="http://schemas.openxmlformats.org/presentationml/2006/main" xmlns:r="http://schemas.openxmlformats.org/officeDocument/2006/relationships">
+  <p:cSld>
+    <p:spTree>
+      <p:nvGrpSpPr>
+        <p:cNvPr id="1" name=""/>
+        <p:cNvGrpSpPr/>
+        <p:nvPr/>
+      </p:nvGrpSpPr>
+      <p:grpSpPr/>
+      <p:sp>
+        <p:nvSpPr>
+          <p:cNvPr id="2" name="TextBox 1"/>
+          <p:cNvSpPr txBox="1"/>
+          <p:nvPr/>
+        </p:nvSpPr>
+        <p:spPr>
+          <a:xfrm>
+            <a:off x="502920" y="320040"/>
+            <a:ext cx="11155680" cy="777240"/>
+          </a:xfrm>
+          <a:prstGeom prst="rect">
+            <a:avLst/>
+          </a:prstGeom>
+          <a:noFill/>
+        </p:spPr>
+        <p:txBody>
+          <a:bodyPr wrap="none">
+            <a:spAutoFit/>
+          </a:bodyPr>
+          <a:lstStyle/>
+          <a:p>
+            <a:pPr>
+              <a:defRPr sz="2800" b="1">
+                <a:solidFill>
+                  <a:srgbClr val="1A365D"/>
+                </a:solidFill>
+              </a:defRPr>
+            </a:pPr>
+            <a:r>
+              <a:t>I/O sterowane przerwaniami</a:t>
+            </a:r>
+          </a:p>
+        </p:txBody>
+      </p:sp>
+      <p:sp>
+        <p:nvSpPr>
+          <p:cNvPr id="3" name="TextBox 2"/>
+          <p:cNvSpPr txBox="1"/>
+          <p:nvPr/>
+        </p:nvSpPr>
+        <p:spPr>
+          <a:xfrm>
+            <a:off x="594360" y="1143000"/>
+            <a:ext cx="10972800" cy="5394960"/>
+          </a:xfrm>
+          <a:prstGeom prst="rect">
+            <a:avLst/>
+          </a:prstGeom>
+          <a:noFill/>
+        </p:spPr>
+        <p:txBody>
+          <a:bodyPr wrap="square">
+            <a:spAutoFit/>
+          </a:bodyPr>
+          <a:lstStyle/>
+          <a:p>
+            <a:pPr>
+              <a:spcAft>
+                <a:spcPts val="800"/>
+              </a:spcAft>
+              <a:defRPr sz="1900">
+                <a:solidFill>
+                  <a:srgbClr val="333333"/>
+                </a:solidFill>
+              </a:defRPr>
+            </a:pPr>
+            <a:r>
+              <a:t>CPU wysyła polecenie do kontrolera, a potem przełącza się na inny proces zamiast kręcić pętlę oczekiwania.</a:t>
+            </a:r>
+          </a:p>
+          <a:p>
+            <a:pPr>
+              <a:spcAft>
+                <a:spcPts val="800"/>
+              </a:spcAft>
+              <a:defRPr sz="1900">
+                <a:solidFill>
+                  <a:srgbClr val="333333"/>
+                </a:solidFill>
+              </a:defRPr>
+            </a:pPr>
+            <a:r>
+              <a:t>Gdy urządzenie kończy pracę, podnosi linię IRQ — procesor po instrukcji sprawdza wektor przerwań i skacze do obsługi przerwania.</a:t>
+            </a:r>
+          </a:p>
+          <a:p>
+            <a:pPr>
+              <a:spcAft>
+                <a:spcPts val="800"/>
+              </a:spcAft>
+              <a:defRPr sz="1900">
+                <a:solidFill>
+                  <a:srgbClr val="333333"/>
+                </a:solidFill>
+              </a:defRPr>
+            </a:pPr>
+            <a:r>
+              <a:t>ISR (Interrupt Service Routine): krótki kod jądra — np. skopiowanie danych z bufora, odblokowanie procesu czekającego na I/O.</a:t>
+            </a:r>
+          </a:p>
+          <a:p>
+            <a:pPr>
+              <a:spcAft>
+                <a:spcPts val="800"/>
+              </a:spcAft>
+              <a:defRPr sz="1900">
+                <a:solidFill>
+                  <a:srgbClr val="333333"/>
+                </a:solidFill>
+              </a:defRPr>
+            </a:pPr>
+            <a:r>
+              <a:t>Koszt: zapis/odczyt rejestrów, zmiana kontekstu — opłaca się, gdy urządzenie pracuje „w tle” dłużej niż kilka instrukcji.</a:t>
+            </a:r>
+          </a:p>
+          <a:p>
+            <a:pPr>
+              <a:spcAft>
+                <a:spcPts val="800"/>
+              </a:spcAft>
+              <a:defRPr sz="1900">
+                <a:solidFill>
+                  <a:srgbClr val="333333"/>
+                </a:solidFill>
+              </a:defRPr>
+            </a:pPr>
+            <a:r>
+              <a:t>Przy wielu urządzeniach: priorytety przerwań, maskowanie, obsługa zagnieżdżona (ważne w jądrze SO).</a:t>
+            </a:r>
+          </a:p>
+        </p:txBody>
+      </p:sp>
+    </p:spTree>
+  </p:cSld>
+  <p:clrMapOvr>
+    <a:masterClrMapping/>
+  </p:clrMapOvr>
+</p:sld>
+</file>
+
+<file path=ppt/slides/slide7.xml><?xml version="1.0" encoding="utf-8"?>
+<p:sld xmlns:a="http://schemas.openxmlformats.org/drawingml/2006/main" xmlns:p="http://schemas.openxmlformats.org/presentationml/2006/main" xmlns:r="http://schemas.openxmlformats.org/officeDocument/2006/relationships">
+  <p:cSld>
+    <p:spTree>
+      <p:nvGrpSpPr>
+        <p:cNvPr id="1" name=""/>
+        <p:cNvGrpSpPr/>
+        <p:nvPr/>
+      </p:nvGrpSpPr>
+      <p:grpSpPr/>
+      <p:sp>
+        <p:nvSpPr>
+          <p:cNvPr id="2" name="TextBox 1"/>
+          <p:cNvSpPr txBox="1"/>
+          <p:nvPr/>
+        </p:nvSpPr>
+        <p:spPr>
+          <a:xfrm>
+            <a:off x="502920" y="320040"/>
+            <a:ext cx="11155680" cy="777240"/>
+          </a:xfrm>
+          <a:prstGeom prst="rect">
+            <a:avLst/>
+          </a:prstGeom>
+          <a:noFill/>
+        </p:spPr>
+        <p:txBody>
+          <a:bodyPr wrap="none">
+            <a:spAutoFit/>
+          </a:bodyPr>
+          <a:lstStyle/>
+          <a:p>
+            <a:pPr>
+              <a:defRPr sz="2800" b="1">
+                <a:solidFill>
+                  <a:srgbClr val="1A365D"/>
+                </a:solidFill>
+              </a:defRPr>
+            </a:pPr>
+            <a:r>
+              <a:t>DMA — bezpośredni dostęp do pamięci</a:t>
+            </a:r>
+          </a:p>
+        </p:txBody>
+      </p:sp>
+      <p:sp>
+        <p:nvSpPr>
+          <p:cNvPr id="3" name="TextBox 2"/>
+          <p:cNvSpPr txBox="1"/>
+          <p:nvPr/>
+        </p:nvSpPr>
+        <p:spPr>
+          <a:xfrm>
+            <a:off x="594360" y="1143000"/>
+            <a:ext cx="10972800" cy="5394960"/>
+          </a:xfrm>
+          <a:prstGeom prst="rect">
+            <a:avLst/>
+          </a:prstGeom>
+          <a:noFill/>
+        </p:spPr>
+        <p:txBody>
+          <a:bodyPr wrap="square">
+            <a:spAutoFit/>
+          </a:bodyPr>
+          <a:lstStyle/>
+          <a:p>
+            <a:pPr>
+              <a:spcAft>
+                <a:spcPts val="800"/>
+              </a:spcAft>
+              <a:defRPr sz="1900">
+                <a:solidFill>
+                  <a:srgbClr val="333333"/>
+                </a:solidFill>
+              </a:defRPr>
+            </a:pPr>
+            <a:r>
+              <a:t>DMA (Direct Memory Access): specjalny kontroler (lub logika w urządzeniu) przenosi bloki danych między RAM a buforem urządzenia bez udziału CPU w każdym bajcie.</a:t>
+            </a:r>
+          </a:p>
+          <a:p>
+            <a:pPr>
+              <a:spcAft>
+                <a:spcPts val="800"/>
+              </a:spcAft>
+              <a:defRPr sz="1900">
+                <a:solidFill>
+                  <a:srgbClr val="333333"/>
+                </a:solidFill>
+              </a:defRPr>
+            </a:pPr>
+            <a:r>
+              <a:t>Procesor programuje: adres źródła/docelowy, rozmiar transferu, kierunek — urządzenie staje się chwilowo masterem magistrali (arbitraż, „cycle stealing”).</a:t>
+            </a:r>
+          </a:p>
+          <a:p>
+            <a:pPr>
+              <a:spcAft>
+                <a:spcPts val="800"/>
+              </a:spcAft>
+              <a:defRPr sz="1900">
+                <a:solidFill>
+                  <a:srgbClr val="333333"/>
+                </a:solidFill>
+              </a:defRPr>
+            </a:pPr>
+            <a:r>
+              <a:t>Po zakończeniu bloku — jedno przerwanie zamiast tysięcy przy przesyłaniu sektoru dysku.</a:t>
+            </a:r>
+          </a:p>
+          <a:p>
+            <a:pPr>
+              <a:spcAft>
+                <a:spcPts val="800"/>
+              </a:spcAft>
+              <a:defRPr sz="1900">
+                <a:solidFill>
+                  <a:srgbClr val="333333"/>
+                </a:solidFill>
+              </a:defRPr>
+            </a:pPr>
+            <a:r>
+              <a:t>Typowe zastosowania: dyski, karty sieciowe, kopiowanie do GPU — wszędzie tam, gdzie przepustowość liczy się w MB/s.</a:t>
+            </a:r>
+          </a:p>
+          <a:p>
+            <a:pPr>
+              <a:spcAft>
+                <a:spcPts val="800"/>
+              </a:spcAft>
+              <a:defRPr sz="1900">
+                <a:solidFill>
+                  <a:srgbClr val="333333"/>
+                </a:solidFill>
+              </a:defRPr>
+            </a:pPr>
+            <a:r>
+              <a:t>Warianty: scatter/gather DMA (łańcuch buforów) — ważne przy sieci i dyskach.</a:t>
+            </a:r>
+          </a:p>
+        </p:txBody>
+      </p:sp>
+    </p:spTree>
+  </p:cSld>
+  <p:clrMapOvr>
+    <a:masterClrMapping/>
+  </p:clrMapOvr>
+</p:sld>
+</file>
+
+<file path=ppt/slides/slide8.xml><?xml version="1.0" encoding="utf-8"?>
+<p:sld xmlns:a="http://schemas.openxmlformats.org/drawingml/2006/main" xmlns:p="http://schemas.openxmlformats.org/presentationml/2006/main" xmlns:r="http://schemas.openxmlformats.org/officeDocument/2006/relationships">
+  <p:cSld>
+    <p:spTree>
+      <p:nvGrpSpPr>
+        <p:cNvPr id="1" name=""/>
+        <p:cNvGrpSpPr/>
+        <p:nvPr/>
+      </p:nvGrpSpPr>
+      <p:grpSpPr/>
+      <p:sp>
+        <p:nvSpPr>
+          <p:cNvPr id="2" name="TextBox 1"/>
+          <p:cNvSpPr txBox="1"/>
+          <p:nvPr/>
+        </p:nvSpPr>
+        <p:spPr>
+          <a:xfrm>
+            <a:off x="502920" y="320040"/>
+            <a:ext cx="11155680" cy="777240"/>
+          </a:xfrm>
+          <a:prstGeom prst="rect">
+            <a:avLst/>
+          </a:prstGeom>
+          <a:noFill/>
+        </p:spPr>
+        <p:txBody>
+          <a:bodyPr wrap="none">
+            <a:spAutoFit/>
+          </a:bodyPr>
+          <a:lstStyle/>
+          <a:p>
+            <a:pPr>
+              <a:defRPr sz="2600" b="1">
+                <a:solidFill>
+                  <a:srgbClr val="1A365D"/>
+                </a:solidFill>
+              </a:defRPr>
+            </a:pPr>
+            <a:r>
+              <a:t>Porównanie metod I/O</a:t>
             </a:r>
           </a:p>
         </p:txBody>
@@ -4803,8 +6818,8 @@
           <p:nvPr/>
         </p:nvGraphicFramePr>
         <p:xfrm>
-          <a:off x="548640" y="1325880"/>
-          <a:ext cx="11064240" cy="1920240"/>
+          <a:off x="502920" y="1097280"/>
+          <a:ext cx="11155680" cy="1993391"/>
         </p:xfrm>
         <a:graphic>
           <a:graphicData uri="http://schemas.openxmlformats.org/drawingml/2006/table">
@@ -4813,18 +6828,18 @@
                 <a:tableStyleId>{5C22544A-7EE6-4342-B048-85BDC9FD1C3A}</a:tableStyleId>
               </a:tblPr>
               <a:tblGrid>
-                <a:gridCol w="3688080"/>
-                <a:gridCol w="3688080"/>
-                <a:gridCol w="3688080"/>
+                <a:gridCol w="2011680"/>
+                <a:gridCol w="4114800"/>
+                <a:gridCol w="5029200"/>
               </a:tblGrid>
-              <a:tr h="480060">
+              <a:tr h="498347">
                 <a:tc>
                   <a:txBody>
                     <a:bodyPr/>
                     <a:lstStyle/>
                     <a:p>
                       <a:pPr>
-                        <a:defRPr b="1" sz="1400">
+                        <a:defRPr b="1" sz="1300">
                           <a:solidFill>
                             <a:srgbClr val="FFFFFF"/>
                           </a:solidFill>
@@ -4847,14 +6862,14 @@
                     <a:lstStyle/>
                     <a:p>
                       <a:pPr>
-                        <a:defRPr b="1" sz="1400">
+                        <a:defRPr b="1" sz="1300">
                           <a:solidFill>
                             <a:srgbClr val="FFFFFF"/>
                           </a:solidFill>
                         </a:defRPr>
                       </a:pPr>
                       <a:r>
-                        <a:t>Idea</a:t>
+                        <a:t>Obciążenie CPU</a:t>
                       </a:r>
                     </a:p>
                   </a:txBody>
@@ -4870,14 +6885,14 @@
                     <a:lstStyle/>
                     <a:p>
                       <a:pPr>
-                        <a:defRPr b="1" sz="1400">
+                        <a:defRPr b="1" sz="1300">
                           <a:solidFill>
                             <a:srgbClr val="FFFFFF"/>
                           </a:solidFill>
                         </a:defRPr>
                       </a:pPr>
                       <a:r>
-                        <a:t>Zastosowanie</a:t>
+                        <a:t>Kiedy stosować</a:t>
                       </a:r>
                     </a:p>
                   </a:txBody>
@@ -4888,21 +6903,21 @@
                   </a:tcPr>
                 </a:tc>
               </a:tr>
-              <a:tr h="480060">
+              <a:tr h="498347">
                 <a:tc>
                   <a:txBody>
                     <a:bodyPr/>
                     <a:lstStyle/>
                     <a:p>
                       <a:pPr>
-                        <a:defRPr sz="1300">
+                        <a:defRPr sz="1200">
                           <a:solidFill>
-                            <a:srgbClr val="444444"/>
+                            <a:srgbClr val="333333"/>
                           </a:solidFill>
                         </a:defRPr>
                       </a:pPr>
                       <a:r>
-                        <a:t>Odpytywanie (polling)</a:t>
+                        <a:t>Polling</a:t>
                       </a:r>
                     </a:p>
                   </a:txBody>
@@ -4914,14 +6929,14 @@
                     <a:lstStyle/>
                     <a:p>
                       <a:pPr>
-                        <a:defRPr sz="1300">
+                        <a:defRPr sz="1200">
                           <a:solidFill>
-                            <a:srgbClr val="444444"/>
+                            <a:srgbClr val="333333"/>
                           </a:solidFill>
                         </a:defRPr>
                       </a:pPr>
                       <a:r>
-                        <a:t>CPU w pętli sprawdza gotowość</a:t>
+                        <a:t>Wysokie — CPU czeka aktywnie</a:t>
                       </a:r>
                     </a:p>
                   </a:txBody>
@@ -4933,30 +6948,30 @@
                     <a:lstStyle/>
                     <a:p>
                       <a:pPr>
-                        <a:defRPr sz="1300">
+                        <a:defRPr sz="1200">
                           <a:solidFill>
-                            <a:srgbClr val="444444"/>
+                            <a:srgbClr val="333333"/>
                           </a:solidFill>
                         </a:defRPr>
                       </a:pPr>
                       <a:r>
-                        <a:t>Proste, wolne urządzenia</a:t>
+                        <a:t>Proste sterowniki, bardzo szybkie urządzenia</a:t>
                       </a:r>
                     </a:p>
                   </a:txBody>
                   <a:tcPr/>
                 </a:tc>
               </a:tr>
-              <a:tr h="480060">
+              <a:tr h="498347">
                 <a:tc>
                   <a:txBody>
                     <a:bodyPr/>
                     <a:lstStyle/>
                     <a:p>
                       <a:pPr>
-                        <a:defRPr sz="1300">
+                        <a:defRPr sz="1200">
                           <a:solidFill>
-                            <a:srgbClr val="444444"/>
+                            <a:srgbClr val="333333"/>
                           </a:solidFill>
                         </a:defRPr>
                       </a:pPr>
@@ -4973,14 +6988,14 @@
                     <a:lstStyle/>
                     <a:p>
                       <a:pPr>
-                        <a:defRPr sz="1300">
+                        <a:defRPr sz="1200">
                           <a:solidFill>
-                            <a:srgbClr val="444444"/>
+                            <a:srgbClr val="333333"/>
                           </a:solidFill>
                         </a:defRPr>
                       </a:pPr>
                       <a:r>
-                        <a:t>Urządzenie sygnalizuje zakończenie</a:t>
+                        <a:t>Umiarkowane — ISR + kontekst</a:t>
                       </a:r>
                     </a:p>
                   </a:txBody>
@@ -4992,30 +7007,30 @@
                     <a:lstStyle/>
                     <a:p>
                       <a:pPr>
-                        <a:defRPr sz="1300">
+                        <a:defRPr sz="1200">
                           <a:solidFill>
-                            <a:srgbClr val="444444"/>
+                            <a:srgbClr val="333333"/>
                           </a:solidFill>
                         </a:defRPr>
                       </a:pPr>
                       <a:r>
-                        <a:t>Klawiatura, mysz</a:t>
+                        <a:t>Klawiatura, mysz, timery, umiarkowane transfery</a:t>
                       </a:r>
                     </a:p>
                   </a:txBody>
                   <a:tcPr/>
                 </a:tc>
               </a:tr>
-              <a:tr h="480060">
+              <a:tr h="498350">
                 <a:tc>
                   <a:txBody>
                     <a:bodyPr/>
                     <a:lstStyle/>
                     <a:p>
                       <a:pPr>
-                        <a:defRPr sz="1300">
+                        <a:defRPr sz="1200">
                           <a:solidFill>
-                            <a:srgbClr val="444444"/>
+                            <a:srgbClr val="333333"/>
                           </a:solidFill>
                         </a:defRPr>
                       </a:pPr>
@@ -5032,14 +7047,14 @@
                     <a:lstStyle/>
                     <a:p>
                       <a:pPr>
-                        <a:defRPr sz="1300">
+                        <a:defRPr sz="1200">
                           <a:solidFill>
-                            <a:srgbClr val="444444"/>
+                            <a:srgbClr val="333333"/>
                           </a:solidFill>
                         </a:defRPr>
                       </a:pPr>
                       <a:r>
-                        <a:t>Układ przenosi bloki RAM ↔ urządzenie</a:t>
+                        <a:t>Niskie — init + 1 przerwanie/blok</a:t>
                       </a:r>
                     </a:p>
                   </a:txBody>
@@ -5051,609 +7066,14 @@
                     <a:lstStyle/>
                     <a:p>
                       <a:pPr>
-                        <a:defRPr sz="1300">
+                        <a:defRPr sz="1200">
                           <a:solidFill>
-                            <a:srgbClr val="444444"/>
+                            <a:srgbClr val="333333"/>
                           </a:solidFill>
                         </a:defRPr>
                       </a:pPr>
                       <a:r>
-                        <a:t>Dyski, sieć</a:t>
-                      </a:r>
-                    </a:p>
-                  </a:txBody>
-                  <a:tcPr/>
-                </a:tc>
-              </a:tr>
-            </a:tbl>
-          </a:graphicData>
-        </a:graphic>
-      </p:graphicFrame>
-    </p:spTree>
-  </p:cSld>
-  <p:clrMapOvr>
-    <a:masterClrMapping/>
-  </p:clrMapOvr>
-</p:sld>
-</file>
-
-<file path=ppt/slides/slide5.xml><?xml version="1.0" encoding="utf-8"?>
-<p:sld xmlns:a="http://schemas.openxmlformats.org/drawingml/2006/main" xmlns:p="http://schemas.openxmlformats.org/presentationml/2006/main" xmlns:r="http://schemas.openxmlformats.org/officeDocument/2006/relationships">
-  <p:cSld>
-    <p:spTree>
-      <p:nvGrpSpPr>
-        <p:cNvPr id="1" name=""/>
-        <p:cNvGrpSpPr/>
-        <p:nvPr/>
-      </p:nvGrpSpPr>
-      <p:grpSpPr/>
-      <p:sp>
-        <p:nvSpPr>
-          <p:cNvPr id="2" name="TextBox 1"/>
-          <p:cNvSpPr txBox="1"/>
-          <p:nvPr/>
-        </p:nvSpPr>
-        <p:spPr>
-          <a:xfrm>
-            <a:off x="548640" y="411480"/>
-            <a:ext cx="11064240" cy="822960"/>
-          </a:xfrm>
-          <a:prstGeom prst="rect">
-            <a:avLst/>
-          </a:prstGeom>
-          <a:noFill/>
-        </p:spPr>
-        <p:txBody>
-          <a:bodyPr wrap="none">
-            <a:spAutoFit/>
-          </a:bodyPr>
-          <a:lstStyle/>
-          <a:p>
-            <a:pPr>
-              <a:defRPr sz="3200" b="1">
-                <a:solidFill>
-                  <a:srgbClr val="1A365D"/>
-                </a:solidFill>
-              </a:defRPr>
-            </a:pPr>
-            <a:r>
-              <a:t>Polling, przerwania, DMA</a:t>
-            </a:r>
-          </a:p>
-        </p:txBody>
-      </p:sp>
-      <p:sp>
-        <p:nvSpPr>
-          <p:cNvPr id="3" name="TextBox 2"/>
-          <p:cNvSpPr txBox="1"/>
-          <p:nvPr/>
-        </p:nvSpPr>
-        <p:spPr>
-          <a:xfrm>
-            <a:off x="731520" y="1371600"/>
-            <a:ext cx="10789920" cy="5029200"/>
-          </a:xfrm>
-          <a:prstGeom prst="rect">
-            <a:avLst/>
-          </a:prstGeom>
-          <a:noFill/>
-        </p:spPr>
-        <p:txBody>
-          <a:bodyPr wrap="square">
-            <a:spAutoFit/>
-          </a:bodyPr>
-          <a:lstStyle/>
-          <a:p>
-            <a:pPr>
-              <a:spcAft>
-                <a:spcPts val="1000"/>
-              </a:spcAft>
-              <a:defRPr sz="2200">
-                <a:solidFill>
-                  <a:srgbClr val="444444"/>
-                </a:solidFill>
-              </a:defRPr>
-            </a:pPr>
-            <a:r>
-              <a:t>Polling — prosty, lecz marnuje cykle CPU (aktywne czekanie)</a:t>
-            </a:r>
-          </a:p>
-          <a:p>
-            <a:pPr>
-              <a:spcAft>
-                <a:spcPts val="1000"/>
-              </a:spcAft>
-              <a:defRPr sz="2200">
-                <a:solidFill>
-                  <a:srgbClr val="444444"/>
-                </a:solidFill>
-              </a:defRPr>
-            </a:pPr>
-            <a:r>
-              <a:t>Przerwania — CPU wykonuje procedurę obsługi przerwania (ISR)</a:t>
-            </a:r>
-          </a:p>
-          <a:p>
-            <a:pPr>
-              <a:spcAft>
-                <a:spcPts val="1000"/>
-              </a:spcAft>
-              <a:defRPr sz="2200">
-                <a:solidFill>
-                  <a:srgbClr val="444444"/>
-                </a:solidFill>
-              </a:defRPr>
-            </a:pPr>
-            <a:r>
-              <a:t>DMA — procesor inicjuje transfer; po bloku jedno przerwanie</a:t>
-            </a:r>
-          </a:p>
-        </p:txBody>
-      </p:sp>
-    </p:spTree>
-  </p:cSld>
-  <p:clrMapOvr>
-    <a:masterClrMapping/>
-  </p:clrMapOvr>
-</p:sld>
-</file>
-
-<file path=ppt/slides/slide6.xml><?xml version="1.0" encoding="utf-8"?>
-<p:sld xmlns:a="http://schemas.openxmlformats.org/drawingml/2006/main" xmlns:p="http://schemas.openxmlformats.org/presentationml/2006/main" xmlns:r="http://schemas.openxmlformats.org/officeDocument/2006/relationships">
-  <p:cSld>
-    <p:spTree>
-      <p:nvGrpSpPr>
-        <p:cNvPr id="1" name=""/>
-        <p:cNvGrpSpPr/>
-        <p:nvPr/>
-      </p:nvGrpSpPr>
-      <p:grpSpPr/>
-      <p:sp>
-        <p:nvSpPr>
-          <p:cNvPr id="2" name="TextBox 1"/>
-          <p:cNvSpPr txBox="1"/>
-          <p:nvPr/>
-        </p:nvSpPr>
-        <p:spPr>
-          <a:xfrm>
-            <a:off x="548640" y="411480"/>
-            <a:ext cx="11064240" cy="822960"/>
-          </a:xfrm>
-          <a:prstGeom prst="rect">
-            <a:avLst/>
-          </a:prstGeom>
-          <a:noFill/>
-        </p:spPr>
-        <p:txBody>
-          <a:bodyPr wrap="none">
-            <a:spAutoFit/>
-          </a:bodyPr>
-          <a:lstStyle/>
-          <a:p>
-            <a:pPr>
-              <a:defRPr sz="3200" b="1">
-                <a:solidFill>
-                  <a:srgbClr val="1A365D"/>
-                </a:solidFill>
-              </a:defRPr>
-            </a:pPr>
-            <a:r>
-              <a:t>Przerwania i spooling</a:t>
-            </a:r>
-          </a:p>
-        </p:txBody>
-      </p:sp>
-      <p:sp>
-        <p:nvSpPr>
-          <p:cNvPr id="3" name="TextBox 2"/>
-          <p:cNvSpPr txBox="1"/>
-          <p:nvPr/>
-        </p:nvSpPr>
-        <p:spPr>
-          <a:xfrm>
-            <a:off x="731520" y="1371600"/>
-            <a:ext cx="10789920" cy="5029200"/>
-          </a:xfrm>
-          <a:prstGeom prst="rect">
-            <a:avLst/>
-          </a:prstGeom>
-          <a:noFill/>
-        </p:spPr>
-        <p:txBody>
-          <a:bodyPr wrap="square">
-            <a:spAutoFit/>
-          </a:bodyPr>
-          <a:lstStyle/>
-          <a:p>
-            <a:pPr>
-              <a:spcAft>
-                <a:spcPts val="1000"/>
-              </a:spcAft>
-              <a:defRPr sz="2200">
-                <a:solidFill>
-                  <a:srgbClr val="444444"/>
-                </a:solidFill>
-              </a:defRPr>
-            </a:pPr>
-            <a:r>
-              <a:t>Wiele przerwań: obsługa sekwencyjna, zagnieżdżona lub priorytetowa</a:t>
-            </a:r>
-          </a:p>
-          <a:p>
-            <a:pPr>
-              <a:spcAft>
-                <a:spcPts val="1000"/>
-              </a:spcAft>
-              <a:defRPr sz="2200">
-                <a:solidFill>
-                  <a:srgbClr val="444444"/>
-                </a:solidFill>
-              </a:defRPr>
-            </a:pPr>
-            <a:r>
-              <a:t>Spooling — buforowanie strumienia na dysku (np. kolejka wydruków)</a:t>
-            </a:r>
-          </a:p>
-          <a:p>
-            <a:pPr>
-              <a:spcAft>
-                <a:spcPts val="1000"/>
-              </a:spcAft>
-              <a:defRPr sz="2200">
-                <a:solidFill>
-                  <a:srgbClr val="444444"/>
-                </a:solidFill>
-              </a:defRPr>
-            </a:pPr>
-            <a:r>
-              <a:t>Powiązanie z SO: planowanie, kolejki urządzeń</a:t>
-            </a:r>
-          </a:p>
-        </p:txBody>
-      </p:sp>
-    </p:spTree>
-  </p:cSld>
-  <p:clrMapOvr>
-    <a:masterClrMapping/>
-  </p:clrMapOvr>
-</p:sld>
-</file>
-
-<file path=ppt/slides/slide7.xml><?xml version="1.0" encoding="utf-8"?>
-<p:sld xmlns:a="http://schemas.openxmlformats.org/drawingml/2006/main" xmlns:p="http://schemas.openxmlformats.org/presentationml/2006/main" xmlns:r="http://schemas.openxmlformats.org/officeDocument/2006/relationships">
-  <p:cSld>
-    <p:spTree>
-      <p:nvGrpSpPr>
-        <p:cNvPr id="1" name=""/>
-        <p:cNvGrpSpPr/>
-        <p:nvPr/>
-      </p:nvGrpSpPr>
-      <p:grpSpPr/>
-      <p:sp>
-        <p:nvSpPr>
-          <p:cNvPr id="2" name="TextBox 1"/>
-          <p:cNvSpPr txBox="1"/>
-          <p:nvPr/>
-        </p:nvSpPr>
-        <p:spPr>
-          <a:xfrm>
-            <a:off x="548640" y="411480"/>
-            <a:ext cx="11064240" cy="822960"/>
-          </a:xfrm>
-          <a:prstGeom prst="rect">
-            <a:avLst/>
-          </a:prstGeom>
-          <a:noFill/>
-        </p:spPr>
-        <p:txBody>
-          <a:bodyPr wrap="none">
-            <a:spAutoFit/>
-          </a:bodyPr>
-          <a:lstStyle/>
-          <a:p>
-            <a:pPr>
-              <a:defRPr sz="3200" b="1">
-                <a:solidFill>
-                  <a:srgbClr val="1A365D"/>
-                </a:solidFill>
-              </a:defRPr>
-            </a:pPr>
-            <a:r>
-              <a:t>Magistrala systemowa</a:t>
-            </a:r>
-          </a:p>
-        </p:txBody>
-      </p:sp>
-      <p:sp>
-        <p:nvSpPr>
-          <p:cNvPr id="3" name="TextBox 2"/>
-          <p:cNvSpPr txBox="1"/>
-          <p:nvPr/>
-        </p:nvSpPr>
-        <p:spPr>
-          <a:xfrm>
-            <a:off x="731520" y="1371600"/>
-            <a:ext cx="10789920" cy="5029200"/>
-          </a:xfrm>
-          <a:prstGeom prst="rect">
-            <a:avLst/>
-          </a:prstGeom>
-          <a:noFill/>
-        </p:spPr>
-        <p:txBody>
-          <a:bodyPr wrap="square">
-            <a:spAutoFit/>
-          </a:bodyPr>
-          <a:lstStyle/>
-          <a:p>
-            <a:pPr>
-              <a:spcAft>
-                <a:spcPts val="1000"/>
-              </a:spcAft>
-              <a:defRPr sz="2200">
-                <a:solidFill>
-                  <a:srgbClr val="444444"/>
-                </a:solidFill>
-              </a:defRPr>
-            </a:pPr>
-            <a:r>
-              <a:t>Wspólne linie + logika sterująca + protokół wymiany danych</a:t>
-            </a:r>
-          </a:p>
-          <a:p>
-            <a:pPr>
-              <a:spcAft>
-                <a:spcPts val="1000"/>
-              </a:spcAft>
-              <a:defRPr sz="2200">
-                <a:solidFill>
-                  <a:srgbClr val="444444"/>
-                </a:solidFill>
-              </a:defRPr>
-            </a:pPr>
-            <a:r>
-              <a:t>Łączy: CPU, pamięć RAM, kontrolery I/O</a:t>
-            </a:r>
-          </a:p>
-        </p:txBody>
-      </p:sp>
-    </p:spTree>
-  </p:cSld>
-  <p:clrMapOvr>
-    <a:masterClrMapping/>
-  </p:clrMapOvr>
-</p:sld>
-</file>
-
-<file path=ppt/slides/slide8.xml><?xml version="1.0" encoding="utf-8"?>
-<p:sld xmlns:a="http://schemas.openxmlformats.org/drawingml/2006/main" xmlns:p="http://schemas.openxmlformats.org/presentationml/2006/main" xmlns:r="http://schemas.openxmlformats.org/officeDocument/2006/relationships">
-  <p:cSld>
-    <p:spTree>
-      <p:nvGrpSpPr>
-        <p:cNvPr id="1" name=""/>
-        <p:cNvGrpSpPr/>
-        <p:nvPr/>
-      </p:nvGrpSpPr>
-      <p:grpSpPr/>
-      <p:sp>
-        <p:nvSpPr>
-          <p:cNvPr id="2" name="TextBox 1"/>
-          <p:cNvSpPr txBox="1"/>
-          <p:nvPr/>
-        </p:nvSpPr>
-        <p:spPr>
-          <a:xfrm>
-            <a:off x="548640" y="411480"/>
-            <a:ext cx="11064240" cy="822960"/>
-          </a:xfrm>
-          <a:prstGeom prst="rect">
-            <a:avLst/>
-          </a:prstGeom>
-          <a:noFill/>
-        </p:spPr>
-        <p:txBody>
-          <a:bodyPr wrap="none">
-            <a:spAutoFit/>
-          </a:bodyPr>
-          <a:lstStyle/>
-          <a:p>
-            <a:pPr>
-              <a:defRPr sz="3000" b="1">
-                <a:solidFill>
-                  <a:srgbClr val="1A365D"/>
-                </a:solidFill>
-              </a:defRPr>
-            </a:pPr>
-            <a:r>
-              <a:t>Trzy magistrale</a:t>
-            </a:r>
-          </a:p>
-        </p:txBody>
-      </p:sp>
-      <p:graphicFrame>
-        <p:nvGraphicFramePr>
-          <p:cNvPr id="3" name="Table 2"/>
-          <p:cNvGraphicFramePr>
-            <a:graphicFrameLocks noGrp="1"/>
-          </p:cNvGraphicFramePr>
-          <p:nvPr/>
-        </p:nvGraphicFramePr>
-        <p:xfrm>
-          <a:off x="548640" y="1325880"/>
-          <a:ext cx="11064240" cy="1920240"/>
-        </p:xfrm>
-        <a:graphic>
-          <a:graphicData uri="http://schemas.openxmlformats.org/drawingml/2006/table">
-            <a:tbl>
-              <a:tblPr firstRow="1" bandRow="1">
-                <a:tableStyleId>{5C22544A-7EE6-4342-B048-85BDC9FD1C3A}</a:tableStyleId>
-              </a:tblPr>
-              <a:tblGrid>
-                <a:gridCol w="5532120"/>
-                <a:gridCol w="5532120"/>
-              </a:tblGrid>
-              <a:tr h="480060">
-                <a:tc>
-                  <a:txBody>
-                    <a:bodyPr/>
-                    <a:lstStyle/>
-                    <a:p>
-                      <a:pPr>
-                        <a:defRPr b="1" sz="1400">
-                          <a:solidFill>
-                            <a:srgbClr val="FFFFFF"/>
-                          </a:solidFill>
-                        </a:defRPr>
-                      </a:pPr>
-                      <a:r>
-                        <a:t>Magistrala</a:t>
-                      </a:r>
-                    </a:p>
-                  </a:txBody>
-                  <a:tcPr>
-                    <a:solidFill>
-                      <a:srgbClr val="1A365D"/>
-                    </a:solidFill>
-                  </a:tcPr>
-                </a:tc>
-                <a:tc>
-                  <a:txBody>
-                    <a:bodyPr/>
-                    <a:lstStyle/>
-                    <a:p>
-                      <a:pPr>
-                        <a:defRPr b="1" sz="1400">
-                          <a:solidFill>
-                            <a:srgbClr val="FFFFFF"/>
-                          </a:solidFill>
-                        </a:defRPr>
-                      </a:pPr>
-                      <a:r>
-                        <a:t>Funkcja</a:t>
-                      </a:r>
-                    </a:p>
-                  </a:txBody>
-                  <a:tcPr>
-                    <a:solidFill>
-                      <a:srgbClr val="1A365D"/>
-                    </a:solidFill>
-                  </a:tcPr>
-                </a:tc>
-              </a:tr>
-              <a:tr h="480060">
-                <a:tc>
-                  <a:txBody>
-                    <a:bodyPr/>
-                    <a:lstStyle/>
-                    <a:p>
-                      <a:pPr>
-                        <a:defRPr sz="1300">
-                          <a:solidFill>
-                            <a:srgbClr val="444444"/>
-                          </a:solidFill>
-                        </a:defRPr>
-                      </a:pPr>
-                      <a:r>
-                        <a:t>Adresowa</a:t>
-                      </a:r>
-                    </a:p>
-                  </a:txBody>
-                  <a:tcPr/>
-                </a:tc>
-                <a:tc>
-                  <a:txBody>
-                    <a:bodyPr/>
-                    <a:lstStyle/>
-                    <a:p>
-                      <a:pPr>
-                        <a:defRPr sz="1300">
-                          <a:solidFill>
-                            <a:srgbClr val="444444"/>
-                          </a:solidFill>
-                        </a:defRPr>
-                      </a:pPr>
-                      <a:r>
-                        <a:t>Adres w pamięci lub port I/O (n linii → 2^n adresów)</a:t>
-                      </a:r>
-                    </a:p>
-                  </a:txBody>
-                  <a:tcPr/>
-                </a:tc>
-              </a:tr>
-              <a:tr h="480060">
-                <a:tc>
-                  <a:txBody>
-                    <a:bodyPr/>
-                    <a:lstStyle/>
-                    <a:p>
-                      <a:pPr>
-                        <a:defRPr sz="1300">
-                          <a:solidFill>
-                            <a:srgbClr val="444444"/>
-                          </a:solidFill>
-                        </a:defRPr>
-                      </a:pPr>
-                      <a:r>
-                        <a:t>Danych</a:t>
-                      </a:r>
-                    </a:p>
-                  </a:txBody>
-                  <a:tcPr/>
-                </a:tc>
-                <a:tc>
-                  <a:txBody>
-                    <a:bodyPr/>
-                    <a:lstStyle/>
-                    <a:p>
-                      <a:pPr>
-                        <a:defRPr sz="1300">
-                          <a:solidFill>
-                            <a:srgbClr val="444444"/>
-                          </a:solidFill>
-                        </a:defRPr>
-                      </a:pPr>
-                      <a:r>
-                        <a:t>Przesyłane dane (np. 32/64 bitów na cykl)</a:t>
-                      </a:r>
-                    </a:p>
-                  </a:txBody>
-                  <a:tcPr/>
-                </a:tc>
-              </a:tr>
-              <a:tr h="480060">
-                <a:tc>
-                  <a:txBody>
-                    <a:bodyPr/>
-                    <a:lstStyle/>
-                    <a:p>
-                      <a:pPr>
-                        <a:defRPr sz="1300">
-                          <a:solidFill>
-                            <a:srgbClr val="444444"/>
-                          </a:solidFill>
-                        </a:defRPr>
-                      </a:pPr>
-                      <a:r>
-                        <a:t>Sterująca</a:t>
-                      </a:r>
-                    </a:p>
-                  </a:txBody>
-                  <a:tcPr/>
-                </a:tc>
-                <a:tc>
-                  <a:txBody>
-                    <a:bodyPr/>
-                    <a:lstStyle/>
-                    <a:p>
-                      <a:pPr>
-                        <a:defRPr sz="1300">
-                          <a:solidFill>
-                            <a:srgbClr val="444444"/>
-                          </a:solidFill>
-                        </a:defRPr>
-                      </a:pPr>
-                      <a:r>
-                        <a:t>READ/WRITE, zegar, reset, przerwania</a:t>
+                        <a:t>Dyski, audio wideo, sieć — duże bloki danych</a:t>
                       </a:r>
                     </a:p>
                   </a:txBody>
@@ -5690,8 +7110,8 @@
         </p:nvSpPr>
         <p:spPr>
           <a:xfrm>
-            <a:off x="548640" y="411480"/>
-            <a:ext cx="11064240" cy="822960"/>
+            <a:off x="502920" y="320040"/>
+            <a:ext cx="11155680" cy="777240"/>
           </a:xfrm>
           <a:prstGeom prst="rect">
             <a:avLst/>
@@ -5705,14 +7125,14 @@
           <a:lstStyle/>
           <a:p>
             <a:pPr>
-              <a:defRPr sz="3200" b="1">
+              <a:defRPr sz="2800" b="1">
                 <a:solidFill>
                   <a:srgbClr val="1A365D"/>
                 </a:solidFill>
               </a:defRPr>
             </a:pPr>
             <a:r>
-              <a:t>Ewolucja magistral</a:t>
+              <a:t>Warstwa OS: kolejki, spooling, sterowniki</a:t>
             </a:r>
           </a:p>
         </p:txBody>
@@ -5725,8 +7145,8 @@
         </p:nvSpPr>
         <p:spPr>
           <a:xfrm>
-            <a:off x="731520" y="1371600"/>
-            <a:ext cx="10789920" cy="5029200"/>
+            <a:off x="594360" y="1143000"/>
+            <a:ext cx="10972800" cy="5394960"/>
           </a:xfrm>
           <a:prstGeom prst="rect">
             <a:avLst/>
@@ -5741,46 +7161,46 @@
           <a:p>
             <a:pPr>
               <a:spcAft>
-                <a:spcPts val="1000"/>
-              </a:spcAft>
-              <a:defRPr sz="2200">
-                <a:solidFill>
-                  <a:srgbClr val="444444"/>
-                </a:solidFill>
-              </a:defRPr>
-            </a:pPr>
-            <a:r>
-              <a:t>Równoległe (PCI, AGP, ATA): crosstalk, clock skew przy wysokich częstotliwościach</a:t>
-            </a:r>
-          </a:p>
-          <a:p>
-            <a:pPr>
-              <a:spcAft>
-                <a:spcPts val="1000"/>
-              </a:spcAft>
-              <a:defRPr sz="2200">
-                <a:solidFill>
-                  <a:srgbClr val="444444"/>
-                </a:solidFill>
-              </a:defRPr>
-            </a:pPr>
-            <a:r>
-              <a:t>Szeregowe punkt–punkt (PCIe, SATA, USB): wyższa przepustowość, full-duplex</a:t>
-            </a:r>
-          </a:p>
-          <a:p>
-            <a:pPr>
-              <a:spcAft>
-                <a:spcPts val="1000"/>
-              </a:spcAft>
-              <a:defRPr sz="2200">
-                <a:solidFill>
-                  <a:srgbClr val="444444"/>
-                </a:solidFill>
-              </a:defRPr>
-            </a:pPr>
-            <a:r>
-              <a:t>Dziś dominują: PCI Express, SATA/M.2, USB</a:t>
+                <a:spcPts val="800"/>
+              </a:spcAft>
+              <a:defRPr sz="1900">
+                <a:solidFill>
+                  <a:srgbClr val="333333"/>
+                </a:solidFill>
+              </a:defRPr>
+            </a:pPr>
+            <a:r>
+              <a:t>Sterownik urządzenia (driver) w jądrze tłumaczy ogólne żądania SO na operacje na rejestrach kontrolera.</a:t>
+            </a:r>
+          </a:p>
+          <a:p>
+            <a:pPr>
+              <a:spcAft>
+                <a:spcPts val="800"/>
+              </a:spcAft>
+              <a:defRPr sz="1900">
+                <a:solidFill>
+                  <a:srgbClr val="333333"/>
+                </a:solidFill>
+              </a:defRPr>
+            </a:pPr>
+            <a:r>
+              <a:t>Spooling — strumień wyników (np. wydruk) buforowany na dysku; proces „wysłał do drukarki” i idzie dalej, drukarka pracuje asynchronicznie.</a:t>
+            </a:r>
+          </a:p>
+          <a:p>
+            <a:pPr>
+              <a:spcAft>
+                <a:spcPts val="800"/>
+              </a:spcAft>
+              <a:defRPr sz="1900">
+                <a:solidFill>
+                  <a:srgbClr val="333333"/>
+                </a:solidFill>
+              </a:defRPr>
+            </a:pPr>
+            <a:r>
+              <a:t>SO planuje dostęp do współdzielonych urządzeń (kolejki I/O, scheduler dysku) — to most między sprzętem a abstrakcjami (pliki, gniazda).</a:t>
             </a:r>
           </a:p>
         </p:txBody>

</xml_diff>